<commit_message>
fix(report): correct snapshot contract and validation matrix
</commit_message>
<xml_diff>
--- a/docs/reports/residential_a_f/EOS_Residential_EMS_A-F_Leadership_Report_With_Curves_CN.pptx
+++ b/docs/reports/residential_a_f/EOS_Residential_EMS_A-F_Leadership_Report_With_Curves_CN.pptx
@@ -2,33 +2,33 @@
 <file path=ppt/presentation.xml><?xml version="1.0" encoding="utf-8"?>
 <p:presentation xmlns:p="http://schemas.openxmlformats.org/presentationml/2006/main">
   <p:sldMasterIdLst>
-    <p:sldMasterId xmlns:r="http://schemas.openxmlformats.org/officeDocument/2006/relationships" id="2147483648" r:id="R680a241599654bb8"/>
+    <p:sldMasterId xmlns:r="http://schemas.openxmlformats.org/officeDocument/2006/relationships" id="2147483648" r:id="R8453df9fbfe7475d"/>
   </p:sldMasterIdLst>
   <p:notesMasterIdLst>
-    <p:notesMasterId xmlns:r="http://schemas.openxmlformats.org/officeDocument/2006/relationships" r:id="R554c328680b34110"/>
+    <p:notesMasterId xmlns:r="http://schemas.openxmlformats.org/officeDocument/2006/relationships" r:id="R8c1819c3c50a45ab"/>
   </p:notesMasterIdLst>
   <p:sldIdLst>
-    <p:sldId xmlns:r="http://schemas.openxmlformats.org/officeDocument/2006/relationships" id="256" r:id="R422cdc7f4f994166"/>
-    <p:sldId xmlns:r="http://schemas.openxmlformats.org/officeDocument/2006/relationships" id="257" r:id="Rdfa1062c4aee480c"/>
-    <p:sldId xmlns:r="http://schemas.openxmlformats.org/officeDocument/2006/relationships" id="258" r:id="Ra58d1908dfd04c06"/>
-    <p:sldId xmlns:r="http://schemas.openxmlformats.org/officeDocument/2006/relationships" id="259" r:id="R2c7074b17bdb4d0f"/>
-    <p:sldId xmlns:r="http://schemas.openxmlformats.org/officeDocument/2006/relationships" id="260" r:id="Rdad6b068d0034127"/>
-    <p:sldId xmlns:r="http://schemas.openxmlformats.org/officeDocument/2006/relationships" id="261" r:id="Re73290f6aeb340a6"/>
-    <p:sldId xmlns:r="http://schemas.openxmlformats.org/officeDocument/2006/relationships" id="262" r:id="Rec78d693d6174e2e"/>
-    <p:sldId xmlns:r="http://schemas.openxmlformats.org/officeDocument/2006/relationships" id="263" r:id="R495f39b667014be4"/>
-    <p:sldId xmlns:r="http://schemas.openxmlformats.org/officeDocument/2006/relationships" id="264" r:id="R51568c1de17b46bb"/>
-    <p:sldId xmlns:r="http://schemas.openxmlformats.org/officeDocument/2006/relationships" id="265" r:id="R67a58349b2e14fb7"/>
-    <p:sldId xmlns:r="http://schemas.openxmlformats.org/officeDocument/2006/relationships" id="266" r:id="R9bb1576b1a074063"/>
-    <p:sldId xmlns:r="http://schemas.openxmlformats.org/officeDocument/2006/relationships" id="267" r:id="R74ddf5bd9bfb45fe"/>
-    <p:sldId xmlns:r="http://schemas.openxmlformats.org/officeDocument/2006/relationships" id="268" r:id="Ra09aaf78c26142f9"/>
-    <p:sldId xmlns:r="http://schemas.openxmlformats.org/officeDocument/2006/relationships" id="269" r:id="Rf69a207d45ce4cef"/>
-    <p:sldId xmlns:r="http://schemas.openxmlformats.org/officeDocument/2006/relationships" id="270" r:id="R6ddab1ef931348d0"/>
-    <p:sldId xmlns:r="http://schemas.openxmlformats.org/officeDocument/2006/relationships" id="271" r:id="R55d3b988731a4e24"/>
-    <p:sldId xmlns:r="http://schemas.openxmlformats.org/officeDocument/2006/relationships" id="272" r:id="Rdd3e504c44cc4942"/>
-    <p:sldId xmlns:r="http://schemas.openxmlformats.org/officeDocument/2006/relationships" id="273" r:id="R2cdb0d5b91c7439c"/>
-    <p:sldId xmlns:r="http://schemas.openxmlformats.org/officeDocument/2006/relationships" id="274" r:id="R527b4084f410468c"/>
-    <p:sldId xmlns:r="http://schemas.openxmlformats.org/officeDocument/2006/relationships" id="275" r:id="R3718f87fdf5e4696"/>
-    <p:sldId xmlns:r="http://schemas.openxmlformats.org/officeDocument/2006/relationships" id="276" r:id="Re57ce9e2da334a13"/>
+    <p:sldId xmlns:r="http://schemas.openxmlformats.org/officeDocument/2006/relationships" id="256" r:id="R354a95281746468c"/>
+    <p:sldId xmlns:r="http://schemas.openxmlformats.org/officeDocument/2006/relationships" id="257" r:id="R88118b7291134d9d"/>
+    <p:sldId xmlns:r="http://schemas.openxmlformats.org/officeDocument/2006/relationships" id="258" r:id="R39fd4e082e8e47c9"/>
+    <p:sldId xmlns:r="http://schemas.openxmlformats.org/officeDocument/2006/relationships" id="259" r:id="R2c520c98010b473e"/>
+    <p:sldId xmlns:r="http://schemas.openxmlformats.org/officeDocument/2006/relationships" id="260" r:id="R2cccc993e9764c75"/>
+    <p:sldId xmlns:r="http://schemas.openxmlformats.org/officeDocument/2006/relationships" id="261" r:id="R82ec64b04f014ff9"/>
+    <p:sldId xmlns:r="http://schemas.openxmlformats.org/officeDocument/2006/relationships" id="262" r:id="R1dbf166a09804e9d"/>
+    <p:sldId xmlns:r="http://schemas.openxmlformats.org/officeDocument/2006/relationships" id="263" r:id="Rd1b1d2086f4940a1"/>
+    <p:sldId xmlns:r="http://schemas.openxmlformats.org/officeDocument/2006/relationships" id="264" r:id="R5624ebaa3a234151"/>
+    <p:sldId xmlns:r="http://schemas.openxmlformats.org/officeDocument/2006/relationships" id="265" r:id="R4af0d63816894cb6"/>
+    <p:sldId xmlns:r="http://schemas.openxmlformats.org/officeDocument/2006/relationships" id="266" r:id="Rc863611716f1404e"/>
+    <p:sldId xmlns:r="http://schemas.openxmlformats.org/officeDocument/2006/relationships" id="267" r:id="R8f26f4b70987444b"/>
+    <p:sldId xmlns:r="http://schemas.openxmlformats.org/officeDocument/2006/relationships" id="268" r:id="Rd569a530e4ed46fd"/>
+    <p:sldId xmlns:r="http://schemas.openxmlformats.org/officeDocument/2006/relationships" id="269" r:id="Rd78710b813b8490b"/>
+    <p:sldId xmlns:r="http://schemas.openxmlformats.org/officeDocument/2006/relationships" id="270" r:id="Rb99ef04135804297"/>
+    <p:sldId xmlns:r="http://schemas.openxmlformats.org/officeDocument/2006/relationships" id="271" r:id="Ra712ef5b5c6a4b38"/>
+    <p:sldId xmlns:r="http://schemas.openxmlformats.org/officeDocument/2006/relationships" id="272" r:id="Rcc68cf1f9ed946fa"/>
+    <p:sldId xmlns:r="http://schemas.openxmlformats.org/officeDocument/2006/relationships" id="273" r:id="Rca0f5afed29e40b5"/>
+    <p:sldId xmlns:r="http://schemas.openxmlformats.org/officeDocument/2006/relationships" id="274" r:id="Rc5828f14e7604df9"/>
+    <p:sldId xmlns:r="http://schemas.openxmlformats.org/officeDocument/2006/relationships" id="275" r:id="R27efb8119a9e4a91"/>
+    <p:sldId xmlns:r="http://schemas.openxmlformats.org/officeDocument/2006/relationships" id="276" r:id="R85b9082dcec14811"/>
   </p:sldIdLst>
   <p:sldSz cx="12192000" cy="6858000"/>
   <p:notesSz cx="6858000" cy="9144000"/>
@@ -2534,7 +2534,7 @@
   </p:cSld>
   <p:clrMap bg1="lt1" tx1="dk1" bg2="lt2" tx2="dk2" accent1="accent1" accent2="accent2" accent3="accent3" accent4="accent4" accent5="accent5" accent6="accent6" hlink="hlink" folHlink="folHlink"/>
   <p:sldLayoutIdLst>
-    <p:sldLayoutId xmlns:r="http://schemas.openxmlformats.org/officeDocument/2006/relationships" id="2147483649" r:id="Rea922388baef4137"/>
+    <p:sldLayoutId xmlns:r="http://schemas.openxmlformats.org/officeDocument/2006/relationships" id="2147483649" r:id="R12b29d982f464736"/>
   </p:sldLayoutIdLst>
   <p:txStyles>
     <p:titleStyle>
@@ -4147,10 +4147,10 @@
           <p:nvPr/>
         </p:nvPicPr>
         <p:blipFill>
-          <a:blip xmlns:r="http://schemas.openxmlformats.org/officeDocument/2006/relationships" xmlns:a="http://schemas.openxmlformats.org/drawingml/2006/main" r:embed="Rfce08d02e591448e">
+          <a:blip xmlns:r="http://schemas.openxmlformats.org/officeDocument/2006/relationships" xmlns:a="http://schemas.openxmlformats.org/drawingml/2006/main" r:embed="R437f9d1e510d4b58">
             <a:extLst>
               <a:ext uri="{96DAC541-7B7A-43D3-8B79-37D633B846F1}">
-                <asvg:svgBlip xmlns:asvg="http://schemas.microsoft.com/office/drawing/2016/SVG/main" r:embed="Rcdfc80618a5546ca"/>
+                <asvg:svgBlip xmlns:asvg="http://schemas.microsoft.com/office/drawing/2016/SVG/main" r:embed="R950cd7d4faf44533"/>
               </a:ext>
             </a:extLst>
           </a:blip>
@@ -4492,10 +4492,10 @@
           <p:nvPr/>
         </p:nvPicPr>
         <p:blipFill>
-          <a:blip xmlns:r="http://schemas.openxmlformats.org/officeDocument/2006/relationships" xmlns:a="http://schemas.openxmlformats.org/drawingml/2006/main" r:embed="R2743de84e2aa46b5">
+          <a:blip xmlns:r="http://schemas.openxmlformats.org/officeDocument/2006/relationships" xmlns:a="http://schemas.openxmlformats.org/drawingml/2006/main" r:embed="R2ad338f8e6284a07">
             <a:extLst>
               <a:ext uri="{96DAC541-7B7A-43D3-8B79-37D633B846F1}">
-                <asvg:svgBlip xmlns:asvg="http://schemas.microsoft.com/office/drawing/2016/SVG/main" r:embed="R089422ce76874f27"/>
+                <asvg:svgBlip xmlns:asvg="http://schemas.microsoft.com/office/drawing/2016/SVG/main" r:embed="R92efa8d2e5f94480"/>
               </a:ext>
             </a:extLst>
           </a:blip>
@@ -4837,10 +4837,10 @@
           <p:nvPr/>
         </p:nvPicPr>
         <p:blipFill>
-          <a:blip xmlns:r="http://schemas.openxmlformats.org/officeDocument/2006/relationships" xmlns:a="http://schemas.openxmlformats.org/drawingml/2006/main" r:embed="R776fff7a3a82425f">
+          <a:blip xmlns:r="http://schemas.openxmlformats.org/officeDocument/2006/relationships" xmlns:a="http://schemas.openxmlformats.org/drawingml/2006/main" r:embed="Rb1fc507c48e84951">
             <a:extLst>
               <a:ext uri="{96DAC541-7B7A-43D3-8B79-37D633B846F1}">
-                <asvg:svgBlip xmlns:asvg="http://schemas.microsoft.com/office/drawing/2016/SVG/main" r:embed="Rdd41c933962a472e"/>
+                <asvg:svgBlip xmlns:asvg="http://schemas.microsoft.com/office/drawing/2016/SVG/main" r:embed="Rc8a0b545384e419c"/>
               </a:ext>
             </a:extLst>
           </a:blip>
@@ -10059,7 +10059,7 @@
         </p:xfrm>
         <a:graphic xmlns:a="http://schemas.openxmlformats.org/drawingml/2006/main">
           <a:graphicData uri="http://schemas.openxmlformats.org/drawingml/2006/chart">
-            <c:chart xmlns:r="http://schemas.openxmlformats.org/officeDocument/2006/relationships" xmlns:c="http://schemas.openxmlformats.org/drawingml/2006/chart" r:id="Red108bf3cd1d4f62"/>
+            <c:chart xmlns:r="http://schemas.openxmlformats.org/officeDocument/2006/relationships" xmlns:c="http://schemas.openxmlformats.org/drawingml/2006/chart" r:id="Rd48cd551d0d84b83"/>
           </a:graphicData>
         </a:graphic>
       </p:graphicFrame>
@@ -14564,6 +14564,7 @@
           <a:lstStyle xmlns:a="http://schemas.openxmlformats.org/drawingml/2006/main"/>
           <a:p xmlns:a="http://schemas.openxmlformats.org/drawingml/2006/main">
             <a:pPr>
+              <a:buNone/>
               <a:defRPr sz="675">
                 <a:solidFill>
                   <a:srgbClr val="5B7190"/>
@@ -14579,43 +14580,1288 @@
               <a:t>24 scenarios</a:t>
             </a:r>
           </a:p>
+          <a:p xmlns:a="http://schemas.openxmlformats.org/drawingml/2006/main">
+            <a:pPr>
+              <a:buNone/>
+              <a:defRPr sz="675">
+                <a:solidFill>
+                  <a:srgbClr val="5B7190"/>
+                </a:solidFill>
+              </a:defRPr>
+            </a:pPr>
+            <a:r>
+              <a:rPr sz="675">
+                <a:solidFill>
+                  <a:srgbClr val="5B7190"/>
+                </a:solidFill>
+              </a:rPr>
+              <a:t>48 logical / actual</a:t>
+            </a:r>
+          </a:p>
+        </p:txBody>
+      </p:sp>
+      <p:sp>
+        <p:nvSpPr>
+          <p:cNvPr id="45" name="">
+            <a:extLst xmlns:a="http://schemas.openxmlformats.org/drawingml/2006/main">
+              <a:ext uri="{FF2B5EF4-FFF2-40B4-BE49-F238E27FC236}">
+                <a16:creationId xmlns:a16="http://schemas.microsoft.com/office/drawing/2014/main" id="{79639CEE-E719-4EFF-915F-5FF406000AEF}"/>
+              </a:ext>
+            </a:extLst>
+          </p:cNvPr>
+          <p:cNvSpPr>
+            <a:spLocks xmlns:a="http://schemas.openxmlformats.org/drawingml/2006/main" noGrp="1"/>
+          </p:cNvSpPr>
+          <p:nvPr/>
+        </p:nvSpPr>
+        <p:spPr>
+          <a:xfrm xmlns:a="http://schemas.openxmlformats.org/drawingml/2006/main">
+            <a:off x="2486025" y="3448050"/>
+            <a:ext cx="1476375" cy="438150"/>
+          </a:xfrm>
+          <a:prstGeom xmlns:a="http://schemas.openxmlformats.org/drawingml/2006/main" prst="rect">
+            <a:avLst/>
+          </a:prstGeom>
+          <a:noFill xmlns:a="http://schemas.openxmlformats.org/drawingml/2006/main"/>
+          <a:ln xmlns:a="http://schemas.openxmlformats.org/drawingml/2006/main" w="0">
+            <a:noFill/>
+            <a:prstDash val="solid"/>
+          </a:ln>
+        </p:spPr>
+        <p:txBody>
+          <a:bodyPr xmlns:a="http://schemas.openxmlformats.org/drawingml/2006/main"/>
+          <a:lstStyle xmlns:a="http://schemas.openxmlformats.org/drawingml/2006/main"/>
+          <a:p xmlns:a="http://schemas.openxmlformats.org/drawingml/2006/main">
+            <a:pPr>
+              <a:buNone/>
+              <a:defRPr sz="675">
+                <a:solidFill>
+                  <a:srgbClr val="5B7190"/>
+                </a:solidFill>
+              </a:defRPr>
+            </a:pPr>
+            <a:r>
+              <a:rPr sz="675">
+                <a:solidFill>
+                  <a:srgbClr val="5B7190"/>
+                </a:solidFill>
+              </a:rPr>
+              <a:t>72 scenarios</a:t>
+            </a:r>
+          </a:p>
+          <a:p xmlns:a="http://schemas.openxmlformats.org/drawingml/2006/main">
+            <a:pPr>
+              <a:buNone/>
+              <a:defRPr sz="675">
+                <a:solidFill>
+                  <a:srgbClr val="5B7190"/>
+                </a:solidFill>
+              </a:defRPr>
+            </a:pPr>
+            <a:r>
+              <a:rPr sz="675">
+                <a:solidFill>
+                  <a:srgbClr val="5B7190"/>
+                </a:solidFill>
+              </a:rPr>
+              <a:t>144 paths / 102 actual</a:t>
+            </a:r>
+          </a:p>
+        </p:txBody>
+      </p:sp>
+      <p:sp>
+        <p:nvSpPr>
+          <p:cNvPr id="46" name="">
+            <a:extLst xmlns:a="http://schemas.openxmlformats.org/drawingml/2006/main">
+              <a:ext uri="{FF2B5EF4-FFF2-40B4-BE49-F238E27FC236}">
+                <a16:creationId xmlns:a16="http://schemas.microsoft.com/office/drawing/2014/main" id="{A04714EC-E29F-4179-AC35-52A8D9DA635C}"/>
+              </a:ext>
+            </a:extLst>
+          </p:cNvPr>
+          <p:cNvSpPr>
+            <a:spLocks xmlns:a="http://schemas.openxmlformats.org/drawingml/2006/main" noGrp="1"/>
+          </p:cNvSpPr>
+          <p:nvPr/>
+        </p:nvSpPr>
+        <p:spPr>
+          <a:xfrm xmlns:a="http://schemas.openxmlformats.org/drawingml/2006/main">
+            <a:off x="4257675" y="3448050"/>
+            <a:ext cx="1476375" cy="438150"/>
+          </a:xfrm>
+          <a:prstGeom xmlns:a="http://schemas.openxmlformats.org/drawingml/2006/main" prst="rect">
+            <a:avLst/>
+          </a:prstGeom>
+          <a:noFill xmlns:a="http://schemas.openxmlformats.org/drawingml/2006/main"/>
+          <a:ln xmlns:a="http://schemas.openxmlformats.org/drawingml/2006/main" w="0">
+            <a:noFill/>
+            <a:prstDash val="solid"/>
+          </a:ln>
+        </p:spPr>
+        <p:txBody>
+          <a:bodyPr xmlns:a="http://schemas.openxmlformats.org/drawingml/2006/main"/>
+          <a:lstStyle xmlns:a="http://schemas.openxmlformats.org/drawingml/2006/main"/>
+          <a:p xmlns:a="http://schemas.openxmlformats.org/drawingml/2006/main">
+            <a:pPr>
+              <a:buNone/>
+              <a:defRPr sz="675">
+                <a:solidFill>
+                  <a:srgbClr val="5B7190"/>
+                </a:solidFill>
+              </a:defRPr>
+            </a:pPr>
+            <a:r>
+              <a:rPr sz="675">
+                <a:solidFill>
+                  <a:srgbClr val="5B7190"/>
+                </a:solidFill>
+              </a:rPr>
+              <a:t>39 scenarios</a:t>
+            </a:r>
+          </a:p>
+          <a:p xmlns:a="http://schemas.openxmlformats.org/drawingml/2006/main">
+            <a:pPr>
+              <a:buNone/>
+              <a:defRPr sz="675">
+                <a:solidFill>
+                  <a:srgbClr val="5B7190"/>
+                </a:solidFill>
+              </a:defRPr>
+            </a:pPr>
+            <a:r>
+              <a:rPr sz="675">
+                <a:solidFill>
+                  <a:srgbClr val="5B7190"/>
+                </a:solidFill>
+              </a:rPr>
+              <a:t>78 independent actual</a:t>
+            </a:r>
+          </a:p>
+        </p:txBody>
+      </p:sp>
+      <p:sp>
+        <p:nvSpPr>
+          <p:cNvPr id="47" name="">
+            <a:extLst xmlns:a="http://schemas.openxmlformats.org/drawingml/2006/main">
+              <a:ext uri="{FF2B5EF4-FFF2-40B4-BE49-F238E27FC236}">
+                <a16:creationId xmlns:a16="http://schemas.microsoft.com/office/drawing/2014/main" id="{77914789-B6A8-4A3C-8F0A-5AC70570BC42}"/>
+              </a:ext>
+            </a:extLst>
+          </p:cNvPr>
+          <p:cNvSpPr>
+            <a:spLocks xmlns:a="http://schemas.openxmlformats.org/drawingml/2006/main" noGrp="1"/>
+          </p:cNvSpPr>
+          <p:nvPr/>
+        </p:nvSpPr>
+        <p:spPr>
+          <a:xfrm xmlns:a="http://schemas.openxmlformats.org/drawingml/2006/main">
+            <a:off x="6029325" y="3448050"/>
+            <a:ext cx="1476375" cy="438150"/>
+          </a:xfrm>
+          <a:prstGeom xmlns:a="http://schemas.openxmlformats.org/drawingml/2006/main" prst="rect">
+            <a:avLst/>
+          </a:prstGeom>
+          <a:noFill xmlns:a="http://schemas.openxmlformats.org/drawingml/2006/main"/>
+          <a:ln xmlns:a="http://schemas.openxmlformats.org/drawingml/2006/main" w="0">
+            <a:noFill/>
+            <a:prstDash val="solid"/>
+          </a:ln>
+        </p:spPr>
+        <p:txBody>
+          <a:bodyPr xmlns:a="http://schemas.openxmlformats.org/drawingml/2006/main"/>
+          <a:lstStyle xmlns:a="http://schemas.openxmlformats.org/drawingml/2006/main"/>
+          <a:p xmlns:a="http://schemas.openxmlformats.org/drawingml/2006/main">
+            <a:pPr>
+              <a:buNone/>
+              <a:defRPr sz="675">
+                <a:solidFill>
+                  <a:srgbClr val="5B7190"/>
+                </a:solidFill>
+              </a:defRPr>
+            </a:pPr>
+            <a:r>
+              <a:rPr sz="675">
+                <a:solidFill>
+                  <a:srgbClr val="5B7190"/>
+                </a:solidFill>
+              </a:rPr>
+              <a:t>6 cases · 88 scenario-days</a:t>
+            </a:r>
+          </a:p>
+          <a:p xmlns:a="http://schemas.openxmlformats.org/drawingml/2006/main">
+            <a:pPr>
+              <a:buNone/>
+              <a:defRPr sz="675">
+                <a:solidFill>
+                  <a:srgbClr val="5B7190"/>
+                </a:solidFill>
+              </a:defRPr>
+            </a:pPr>
+            <a:r>
+              <a:rPr sz="675">
+                <a:solidFill>
+                  <a:srgbClr val="5B7190"/>
+                </a:solidFill>
+              </a:rPr>
+              <a:t>12 paths · 176 daily</a:t>
+            </a:r>
+          </a:p>
+        </p:txBody>
+      </p:sp>
+      <p:sp>
+        <p:nvSpPr>
+          <p:cNvPr id="48" name="">
+            <a:extLst xmlns:a="http://schemas.openxmlformats.org/drawingml/2006/main">
+              <a:ext uri="{FF2B5EF4-FFF2-40B4-BE49-F238E27FC236}">
+                <a16:creationId xmlns:a16="http://schemas.microsoft.com/office/drawing/2014/main" id="{9CF8AC9F-85E8-4517-86B4-4781462CD3F2}"/>
+              </a:ext>
+            </a:extLst>
+          </p:cNvPr>
+          <p:cNvSpPr>
+            <a:spLocks xmlns:a="http://schemas.openxmlformats.org/drawingml/2006/main" noGrp="1"/>
+          </p:cNvSpPr>
+          <p:nvPr/>
+        </p:nvSpPr>
+        <p:spPr>
+          <a:xfrm xmlns:a="http://schemas.openxmlformats.org/drawingml/2006/main">
+            <a:off x="7800975" y="3448050"/>
+            <a:ext cx="1476375" cy="438150"/>
+          </a:xfrm>
+          <a:prstGeom xmlns:a="http://schemas.openxmlformats.org/drawingml/2006/main" prst="rect">
+            <a:avLst/>
+          </a:prstGeom>
+          <a:noFill xmlns:a="http://schemas.openxmlformats.org/drawingml/2006/main"/>
+          <a:ln xmlns:a="http://schemas.openxmlformats.org/drawingml/2006/main" w="0">
+            <a:noFill/>
+            <a:prstDash val="solid"/>
+          </a:ln>
+        </p:spPr>
+        <p:txBody>
+          <a:bodyPr xmlns:a="http://schemas.openxmlformats.org/drawingml/2006/main"/>
+          <a:lstStyle xmlns:a="http://schemas.openxmlformats.org/drawingml/2006/main"/>
+          <a:p xmlns:a="http://schemas.openxmlformats.org/drawingml/2006/main">
+            <a:pPr>
+              <a:buNone/>
+              <a:defRPr sz="675">
+                <a:solidFill>
+                  <a:srgbClr val="5B7190"/>
+                </a:solidFill>
+              </a:defRPr>
+            </a:pPr>
+            <a:r>
+              <a:rPr sz="675">
+                <a:solidFill>
+                  <a:srgbClr val="5B7190"/>
+                </a:solidFill>
+              </a:rPr>
+              <a:t>192 samples · 384 paths</a:t>
+            </a:r>
+          </a:p>
+          <a:p xmlns:a="http://schemas.openxmlformats.org/drawingml/2006/main">
+            <a:pPr>
+              <a:buNone/>
+              <a:defRPr sz="675">
+                <a:solidFill>
+                  <a:srgbClr val="5B7190"/>
+                </a:solidFill>
+              </a:defRPr>
+            </a:pPr>
+            <a:r>
+              <a:rPr sz="675">
+                <a:solidFill>
+                  <a:srgbClr val="5B7190"/>
+                </a:solidFill>
+              </a:rPr>
+              <a:t>6 anchors · 390 actual</a:t>
+            </a:r>
+          </a:p>
+        </p:txBody>
+      </p:sp>
+      <p:sp>
+        <p:nvSpPr>
+          <p:cNvPr id="49" name="">
+            <a:extLst xmlns:a="http://schemas.openxmlformats.org/drawingml/2006/main">
+              <a:ext uri="{FF2B5EF4-FFF2-40B4-BE49-F238E27FC236}">
+                <a16:creationId xmlns:a16="http://schemas.microsoft.com/office/drawing/2014/main" id="{D1DAAFE7-9CCF-4A33-AEE9-8834717F808F}"/>
+              </a:ext>
+            </a:extLst>
+          </p:cNvPr>
+          <p:cNvSpPr>
+            <a:spLocks xmlns:a="http://schemas.openxmlformats.org/drawingml/2006/main" noGrp="1"/>
+          </p:cNvSpPr>
+          <p:nvPr/>
+        </p:nvSpPr>
+        <p:spPr>
+          <a:xfrm xmlns:a="http://schemas.openxmlformats.org/drawingml/2006/main">
+            <a:off x="9572625" y="3448050"/>
+            <a:ext cx="1476375" cy="438150"/>
+          </a:xfrm>
+          <a:prstGeom xmlns:a="http://schemas.openxmlformats.org/drawingml/2006/main" prst="rect">
+            <a:avLst/>
+          </a:prstGeom>
+          <a:noFill xmlns:a="http://schemas.openxmlformats.org/drawingml/2006/main"/>
+          <a:ln xmlns:a="http://schemas.openxmlformats.org/drawingml/2006/main" w="0">
+            <a:noFill/>
+            <a:prstDash val="solid"/>
+          </a:ln>
+        </p:spPr>
+        <p:txBody>
+          <a:bodyPr xmlns:a="http://schemas.openxmlformats.org/drawingml/2006/main"/>
+          <a:lstStyle xmlns:a="http://schemas.openxmlformats.org/drawingml/2006/main"/>
+          <a:p xmlns:a="http://schemas.openxmlformats.org/drawingml/2006/main">
+            <a:pPr>
+              <a:buNone/>
+              <a:defRPr sz="675">
+                <a:solidFill>
+                  <a:srgbClr val="5B7190"/>
+                </a:solidFill>
+              </a:defRPr>
+            </a:pPr>
+            <a:r>
+              <a:rPr sz="675">
+                <a:solidFill>
+                  <a:srgbClr val="5B7190"/>
+                </a:solidFill>
+              </a:rPr>
+              <a:t>60 scenarios · 420 scenario-days</a:t>
+            </a:r>
+          </a:p>
+          <a:p xmlns:a="http://schemas.openxmlformats.org/drawingml/2006/main">
+            <a:pPr>
+              <a:buNone/>
+              <a:defRPr sz="675">
+                <a:solidFill>
+                  <a:srgbClr val="5B7190"/>
+                </a:solidFill>
+              </a:defRPr>
+            </a:pPr>
+            <a:r>
+              <a:rPr sz="675">
+                <a:solidFill>
+                  <a:srgbClr val="5B7190"/>
+                </a:solidFill>
+              </a:rPr>
+              <a:t>126 paths · 882 daily</a:t>
+            </a:r>
+          </a:p>
+        </p:txBody>
+      </p:sp>
+      <p:sp>
+        <p:nvSpPr>
+          <p:cNvPr id="50" name="">
+            <a:extLst xmlns:a="http://schemas.openxmlformats.org/drawingml/2006/main">
+              <a:ext uri="{FF2B5EF4-FFF2-40B4-BE49-F238E27FC236}">
+                <a16:creationId xmlns:a16="http://schemas.microsoft.com/office/drawing/2014/main" id="{23717EB0-1CAC-4BA3-AB0D-443792E2F329}"/>
+              </a:ext>
+            </a:extLst>
+          </p:cNvPr>
+          <p:cNvSpPr>
+            <a:spLocks xmlns:a="http://schemas.openxmlformats.org/drawingml/2006/main" noGrp="1"/>
+          </p:cNvSpPr>
+          <p:nvPr/>
+        </p:nvSpPr>
+        <p:spPr>
+          <a:xfrm xmlns:a="http://schemas.openxmlformats.org/drawingml/2006/main">
+            <a:off x="571500" y="1619250"/>
+            <a:ext cx="11049000" cy="4667250"/>
+          </a:xfrm>
+          <a:prstGeom xmlns:a="http://schemas.openxmlformats.org/drawingml/2006/main" prst="rect">
+            <a:avLst/>
+          </a:prstGeom>
+          <a:solidFill xmlns:a="http://schemas.openxmlformats.org/drawingml/2006/main">
+            <a:srgbClr val="FFFFFF"/>
+          </a:solidFill>
+          <a:ln xmlns:a="http://schemas.openxmlformats.org/drawingml/2006/main" w="9525">
+            <a:solidFill>
+              <a:srgbClr val="FFFFFF"/>
+            </a:solidFill>
+            <a:prstDash val="solid"/>
+          </a:ln>
+        </p:spPr>
+      </p:sp>
+      <p:sp>
+        <p:nvSpPr>
+          <p:cNvPr id="51" name="">
+            <a:extLst xmlns:a="http://schemas.openxmlformats.org/drawingml/2006/main">
+              <a:ext uri="{FF2B5EF4-FFF2-40B4-BE49-F238E27FC236}">
+                <a16:creationId xmlns:a16="http://schemas.microsoft.com/office/drawing/2014/main" id="{20D359C0-89B8-43F4-BCCB-5C06F1ED3D00}"/>
+              </a:ext>
+            </a:extLst>
+          </p:cNvPr>
+          <p:cNvSpPr>
+            <a:spLocks xmlns:a="http://schemas.openxmlformats.org/drawingml/2006/main" noGrp="1"/>
+          </p:cNvSpPr>
+          <p:nvPr/>
+        </p:nvSpPr>
+        <p:spPr>
+          <a:xfrm xmlns:a="http://schemas.openxmlformats.org/drawingml/2006/main">
+            <a:off x="4152900" y="2524125"/>
+            <a:ext cx="171450" cy="0"/>
+          </a:xfrm>
+          <a:prstGeom xmlns:a="http://schemas.openxmlformats.org/drawingml/2006/main" prst="line">
+            <a:avLst/>
+          </a:prstGeom>
+          <a:ln xmlns:a="http://schemas.openxmlformats.org/drawingml/2006/main" w="19050">
+            <a:solidFill>
+              <a:srgbClr val="5B7190"/>
+            </a:solidFill>
+            <a:prstDash val="solid"/>
+          </a:ln>
+        </p:spPr>
+      </p:sp>
+      <p:sp>
+        <p:nvSpPr>
+          <p:cNvPr id="52" name="">
+            <a:extLst xmlns:a="http://schemas.openxmlformats.org/drawingml/2006/main">
+              <a:ext uri="{FF2B5EF4-FFF2-40B4-BE49-F238E27FC236}">
+                <a16:creationId xmlns:a16="http://schemas.microsoft.com/office/drawing/2014/main" id="{058BDEB4-24CB-4F61-9D15-ACB872C61DC7}"/>
+              </a:ext>
+            </a:extLst>
+          </p:cNvPr>
+          <p:cNvSpPr>
+            <a:spLocks xmlns:a="http://schemas.openxmlformats.org/drawingml/2006/main" noGrp="1"/>
+          </p:cNvSpPr>
+          <p:nvPr/>
+        </p:nvSpPr>
+        <p:spPr>
+          <a:xfrm xmlns:a="http://schemas.openxmlformats.org/drawingml/2006/main">
+            <a:off x="7867650" y="2524125"/>
+            <a:ext cx="171450" cy="0"/>
+          </a:xfrm>
+          <a:prstGeom xmlns:a="http://schemas.openxmlformats.org/drawingml/2006/main" prst="line">
+            <a:avLst/>
+          </a:prstGeom>
+          <a:ln xmlns:a="http://schemas.openxmlformats.org/drawingml/2006/main" w="19050">
+            <a:solidFill>
+              <a:srgbClr val="5B7190"/>
+            </a:solidFill>
+            <a:prstDash val="solid"/>
+          </a:ln>
+        </p:spPr>
+      </p:sp>
+      <p:sp>
+        <p:nvSpPr>
+          <p:cNvPr id="53" name="">
+            <a:extLst xmlns:a="http://schemas.openxmlformats.org/drawingml/2006/main">
+              <a:ext uri="{FF2B5EF4-FFF2-40B4-BE49-F238E27FC236}">
+                <a16:creationId xmlns:a16="http://schemas.microsoft.com/office/drawing/2014/main" id="{1151F312-1050-4FA6-8BE6-B15B0290C22F}"/>
+              </a:ext>
+            </a:extLst>
+          </p:cNvPr>
+          <p:cNvSpPr>
+            <a:spLocks xmlns:a="http://schemas.openxmlformats.org/drawingml/2006/main" noGrp="1"/>
+          </p:cNvSpPr>
+          <p:nvPr/>
+        </p:nvSpPr>
+        <p:spPr>
+          <a:xfrm xmlns:a="http://schemas.openxmlformats.org/drawingml/2006/main">
+            <a:off x="4152900" y="4286250"/>
+            <a:ext cx="171450" cy="0"/>
+          </a:xfrm>
+          <a:prstGeom xmlns:a="http://schemas.openxmlformats.org/drawingml/2006/main" prst="line">
+            <a:avLst/>
+          </a:prstGeom>
+          <a:ln xmlns:a="http://schemas.openxmlformats.org/drawingml/2006/main" w="19050">
+            <a:solidFill>
+              <a:srgbClr val="5B7190"/>
+            </a:solidFill>
+            <a:prstDash val="solid"/>
+          </a:ln>
+        </p:spPr>
+      </p:sp>
+      <p:sp>
+        <p:nvSpPr>
+          <p:cNvPr id="54" name="">
+            <a:extLst xmlns:a="http://schemas.openxmlformats.org/drawingml/2006/main">
+              <a:ext uri="{FF2B5EF4-FFF2-40B4-BE49-F238E27FC236}">
+                <a16:creationId xmlns:a16="http://schemas.microsoft.com/office/drawing/2014/main" id="{421430CC-7A54-40D5-B96A-EAFC73D774DE}"/>
+              </a:ext>
+            </a:extLst>
+          </p:cNvPr>
+          <p:cNvSpPr>
+            <a:spLocks xmlns:a="http://schemas.openxmlformats.org/drawingml/2006/main" noGrp="1"/>
+          </p:cNvSpPr>
+          <p:nvPr/>
+        </p:nvSpPr>
+        <p:spPr>
+          <a:xfrm xmlns:a="http://schemas.openxmlformats.org/drawingml/2006/main">
+            <a:off x="7867650" y="4286250"/>
+            <a:ext cx="171450" cy="0"/>
+          </a:xfrm>
+          <a:prstGeom xmlns:a="http://schemas.openxmlformats.org/drawingml/2006/main" prst="line">
+            <a:avLst/>
+          </a:prstGeom>
+          <a:ln xmlns:a="http://schemas.openxmlformats.org/drawingml/2006/main" w="19050">
+            <a:solidFill>
+              <a:srgbClr val="5B7190"/>
+            </a:solidFill>
+            <a:prstDash val="solid"/>
+          </a:ln>
+        </p:spPr>
+      </p:sp>
+      <p:sp>
+        <p:nvSpPr>
+          <p:cNvPr id="55" name="">
+            <a:extLst xmlns:a="http://schemas.openxmlformats.org/drawingml/2006/main">
+              <a:ext uri="{FF2B5EF4-FFF2-40B4-BE49-F238E27FC236}">
+                <a16:creationId xmlns:a16="http://schemas.microsoft.com/office/drawing/2014/main" id="{BD32A311-A838-43A3-9524-3B9B7B280CFE}"/>
+              </a:ext>
+            </a:extLst>
+          </p:cNvPr>
+          <p:cNvSpPr>
+            <a:spLocks xmlns:a="http://schemas.openxmlformats.org/drawingml/2006/main" noGrp="1"/>
+          </p:cNvSpPr>
+          <p:nvPr/>
+        </p:nvSpPr>
+        <p:spPr>
+          <a:xfrm xmlns:a="http://schemas.openxmlformats.org/drawingml/2006/main">
+            <a:off x="9906000" y="3305175"/>
+            <a:ext cx="0" cy="95250"/>
+          </a:xfrm>
+          <a:prstGeom xmlns:a="http://schemas.openxmlformats.org/drawingml/2006/main" prst="line">
+            <a:avLst/>
+          </a:prstGeom>
+          <a:ln xmlns:a="http://schemas.openxmlformats.org/drawingml/2006/main" w="19050">
+            <a:solidFill>
+              <a:srgbClr val="5B7190"/>
+            </a:solidFill>
+            <a:prstDash val="solid"/>
+          </a:ln>
+        </p:spPr>
+      </p:sp>
+      <p:sp>
+        <p:nvSpPr>
+          <p:cNvPr id="56" name="">
+            <a:extLst xmlns:a="http://schemas.openxmlformats.org/drawingml/2006/main">
+              <a:ext uri="{FF2B5EF4-FFF2-40B4-BE49-F238E27FC236}">
+                <a16:creationId xmlns:a16="http://schemas.microsoft.com/office/drawing/2014/main" id="{061691E5-9D1D-4274-8D9E-CD48BD02450C}"/>
+              </a:ext>
+            </a:extLst>
+          </p:cNvPr>
+          <p:cNvSpPr>
+            <a:spLocks xmlns:a="http://schemas.openxmlformats.org/drawingml/2006/main" noGrp="1"/>
+          </p:cNvSpPr>
+          <p:nvPr/>
+        </p:nvSpPr>
+        <p:spPr>
+          <a:xfrm xmlns:a="http://schemas.openxmlformats.org/drawingml/2006/main">
+            <a:off x="666750" y="1762125"/>
+            <a:ext cx="3429000" cy="1524000"/>
+          </a:xfrm>
+          <a:prstGeom xmlns:a="http://schemas.openxmlformats.org/drawingml/2006/main" prst="rect">
+            <a:avLst/>
+          </a:prstGeom>
+          <a:solidFill xmlns:a="http://schemas.openxmlformats.org/drawingml/2006/main">
+            <a:srgbClr val="EAF4FC"/>
+          </a:solidFill>
+          <a:ln xmlns:a="http://schemas.openxmlformats.org/drawingml/2006/main" w="9525">
+            <a:solidFill>
+              <a:srgbClr val="C7DDF0"/>
+            </a:solidFill>
+            <a:prstDash val="solid"/>
+          </a:ln>
+        </p:spPr>
+      </p:sp>
+      <p:sp>
+        <p:nvSpPr>
+          <p:cNvPr id="57" name="">
+            <a:extLst xmlns:a="http://schemas.openxmlformats.org/drawingml/2006/main">
+              <a:ext uri="{FF2B5EF4-FFF2-40B4-BE49-F238E27FC236}">
+                <a16:creationId xmlns:a16="http://schemas.microsoft.com/office/drawing/2014/main" id="{D4E7475C-E007-44F0-8F93-FFDD7D687C68}"/>
+              </a:ext>
+            </a:extLst>
+          </p:cNvPr>
+          <p:cNvSpPr>
+            <a:spLocks xmlns:a="http://schemas.openxmlformats.org/drawingml/2006/main" noGrp="1"/>
+          </p:cNvSpPr>
+          <p:nvPr/>
+        </p:nvSpPr>
+        <p:spPr>
+          <a:xfrm xmlns:a="http://schemas.openxmlformats.org/drawingml/2006/main">
+            <a:off x="666750" y="1762125"/>
+            <a:ext cx="66675" cy="1524000"/>
+          </a:xfrm>
+          <a:prstGeom xmlns:a="http://schemas.openxmlformats.org/drawingml/2006/main" prst="rect">
+            <a:avLst/>
+          </a:prstGeom>
+          <a:solidFill xmlns:a="http://schemas.openxmlformats.org/drawingml/2006/main">
+            <a:srgbClr val="1D70B8"/>
+          </a:solidFill>
+          <a:ln xmlns:a="http://schemas.openxmlformats.org/drawingml/2006/main" w="9525">
+            <a:solidFill>
+              <a:srgbClr val="1D70B8"/>
+            </a:solidFill>
+            <a:prstDash val="solid"/>
+          </a:ln>
+        </p:spPr>
+      </p:sp>
+      <p:sp>
+        <p:nvSpPr>
+          <p:cNvPr id="58" name="">
+            <a:extLst xmlns:a="http://schemas.openxmlformats.org/drawingml/2006/main">
+              <a:ext uri="{FF2B5EF4-FFF2-40B4-BE49-F238E27FC236}">
+                <a16:creationId xmlns:a16="http://schemas.microsoft.com/office/drawing/2014/main" id="{7762CE33-BD89-4D14-9DBC-BFCC826CADB2}"/>
+              </a:ext>
+            </a:extLst>
+          </p:cNvPr>
+          <p:cNvSpPr>
+            <a:spLocks xmlns:a="http://schemas.openxmlformats.org/drawingml/2006/main" noGrp="1"/>
+          </p:cNvSpPr>
+          <p:nvPr/>
+        </p:nvSpPr>
+        <p:spPr>
+          <a:xfrm xmlns:a="http://schemas.openxmlformats.org/drawingml/2006/main">
+            <a:off x="857250" y="1914525"/>
+            <a:ext cx="323850" cy="285750"/>
+          </a:xfrm>
+          <a:prstGeom xmlns:a="http://schemas.openxmlformats.org/drawingml/2006/main" prst="rect">
+            <a:avLst/>
+          </a:prstGeom>
+          <a:noFill xmlns:a="http://schemas.openxmlformats.org/drawingml/2006/main"/>
+          <a:ln xmlns:a="http://schemas.openxmlformats.org/drawingml/2006/main" w="0">
+            <a:noFill/>
+            <a:prstDash val="solid"/>
+          </a:ln>
+        </p:spPr>
+        <p:txBody>
+          <a:bodyPr xmlns:a="http://schemas.openxmlformats.org/drawingml/2006/main"/>
+          <a:lstStyle xmlns:a="http://schemas.openxmlformats.org/drawingml/2006/main"/>
+          <a:p xmlns:a="http://schemas.openxmlformats.org/drawingml/2006/main">
+            <a:pPr>
+              <a:defRPr sz="1725" b="1">
+                <a:solidFill>
+                  <a:srgbClr val="1D70B8"/>
+                </a:solidFill>
+              </a:defRPr>
+            </a:pPr>
+            <a:r>
+              <a:rPr sz="1725" b="1">
+                <a:solidFill>
+                  <a:srgbClr val="1D70B8"/>
+                </a:solidFill>
+              </a:rPr>
+              <a:t>A</a:t>
+            </a:r>
+          </a:p>
+        </p:txBody>
+      </p:sp>
+      <p:sp>
+        <p:nvSpPr>
+          <p:cNvPr id="59" name="">
+            <a:extLst xmlns:a="http://schemas.openxmlformats.org/drawingml/2006/main">
+              <a:ext uri="{FF2B5EF4-FFF2-40B4-BE49-F238E27FC236}">
+                <a16:creationId xmlns:a16="http://schemas.microsoft.com/office/drawing/2014/main" id="{BA279F2E-0056-4B5D-85EA-1A2B586BDE2F}"/>
+              </a:ext>
+            </a:extLst>
+          </p:cNvPr>
+          <p:cNvSpPr>
+            <a:spLocks xmlns:a="http://schemas.openxmlformats.org/drawingml/2006/main" noGrp="1"/>
+          </p:cNvSpPr>
+          <p:nvPr/>
+        </p:nvSpPr>
+        <p:spPr>
+          <a:xfrm xmlns:a="http://schemas.openxmlformats.org/drawingml/2006/main">
+            <a:off x="1276350" y="1924050"/>
+            <a:ext cx="1257300" cy="247650"/>
+          </a:xfrm>
+          <a:prstGeom xmlns:a="http://schemas.openxmlformats.org/drawingml/2006/main" prst="rect">
+            <a:avLst/>
+          </a:prstGeom>
+          <a:noFill xmlns:a="http://schemas.openxmlformats.org/drawingml/2006/main"/>
+          <a:ln xmlns:a="http://schemas.openxmlformats.org/drawingml/2006/main" w="0">
+            <a:noFill/>
+            <a:prstDash val="solid"/>
+          </a:ln>
+        </p:spPr>
+        <p:txBody>
+          <a:bodyPr xmlns:a="http://schemas.openxmlformats.org/drawingml/2006/main"/>
+          <a:lstStyle xmlns:a="http://schemas.openxmlformats.org/drawingml/2006/main"/>
+          <a:p xmlns:a="http://schemas.openxmlformats.org/drawingml/2006/main">
+            <a:pPr>
+              <a:defRPr sz="1200" b="1">
+                <a:solidFill>
+                  <a:srgbClr val="0F3456"/>
+                </a:solidFill>
+              </a:defRPr>
+            </a:pPr>
+            <a:r>
+              <a:rPr sz="1200" b="1">
+                <a:solidFill>
+                  <a:srgbClr val="0F3456"/>
+                </a:solidFill>
+              </a:rPr>
+              <a:t>冻结基准</a:t>
+            </a:r>
+          </a:p>
+        </p:txBody>
+      </p:sp>
+      <p:sp>
+        <p:nvSpPr>
+          <p:cNvPr id="60" name="">
+            <a:extLst xmlns:a="http://schemas.openxmlformats.org/drawingml/2006/main">
+              <a:ext uri="{FF2B5EF4-FFF2-40B4-BE49-F238E27FC236}">
+                <a16:creationId xmlns:a16="http://schemas.microsoft.com/office/drawing/2014/main" id="{8A360B1C-59A7-48E8-A61D-FA1564957885}"/>
+              </a:ext>
+            </a:extLst>
+          </p:cNvPr>
+          <p:cNvSpPr>
+            <a:spLocks xmlns:a="http://schemas.openxmlformats.org/drawingml/2006/main" noGrp="1"/>
+          </p:cNvSpPr>
+          <p:nvPr/>
+        </p:nvSpPr>
+        <p:spPr>
+          <a:xfrm xmlns:a="http://schemas.openxmlformats.org/drawingml/2006/main">
+            <a:off x="857250" y="2228850"/>
+            <a:ext cx="3048000" cy="171450"/>
+          </a:xfrm>
+          <a:prstGeom xmlns:a="http://schemas.openxmlformats.org/drawingml/2006/main" prst="rect">
+            <a:avLst/>
+          </a:prstGeom>
+          <a:noFill xmlns:a="http://schemas.openxmlformats.org/drawingml/2006/main"/>
+          <a:ln xmlns:a="http://schemas.openxmlformats.org/drawingml/2006/main" w="0">
+            <a:noFill/>
+            <a:prstDash val="solid"/>
+          </a:ln>
+        </p:spPr>
+        <p:txBody>
+          <a:bodyPr xmlns:a="http://schemas.openxmlformats.org/drawingml/2006/main"/>
+          <a:lstStyle xmlns:a="http://schemas.openxmlformats.org/drawingml/2006/main"/>
+          <a:p xmlns:a="http://schemas.openxmlformats.org/drawingml/2006/main">
+            <a:pPr>
+              <a:defRPr sz="750">
+                <a:solidFill>
+                  <a:srgbClr val="5B7190"/>
+                </a:solidFill>
+              </a:defRPr>
+            </a:pPr>
+            <a:r>
+              <a:rPr sz="750">
+                <a:solidFill>
+                  <a:srgbClr val="5B7190"/>
+                </a:solidFill>
+              </a:rPr>
+              <a:t>确定性日基线与接受性</a:t>
+            </a:r>
+          </a:p>
+        </p:txBody>
+      </p:sp>
+      <p:sp>
+        <p:nvSpPr>
+          <p:cNvPr id="61" name="">
+            <a:extLst xmlns:a="http://schemas.openxmlformats.org/drawingml/2006/main">
+              <a:ext uri="{FF2B5EF4-FFF2-40B4-BE49-F238E27FC236}">
+                <a16:creationId xmlns:a16="http://schemas.microsoft.com/office/drawing/2014/main" id="{6C258225-21B9-45D5-BF12-FCD3E217CD23}"/>
+              </a:ext>
+            </a:extLst>
+          </p:cNvPr>
+          <p:cNvSpPr>
+            <a:spLocks xmlns:a="http://schemas.openxmlformats.org/drawingml/2006/main" noGrp="1"/>
+          </p:cNvSpPr>
+          <p:nvPr/>
+        </p:nvSpPr>
+        <p:spPr>
+          <a:xfrm xmlns:a="http://schemas.openxmlformats.org/drawingml/2006/main">
+            <a:off x="857250" y="2486025"/>
+            <a:ext cx="762000" cy="152400"/>
+          </a:xfrm>
+          <a:prstGeom xmlns:a="http://schemas.openxmlformats.org/drawingml/2006/main" prst="rect">
+            <a:avLst/>
+          </a:prstGeom>
+          <a:noFill xmlns:a="http://schemas.openxmlformats.org/drawingml/2006/main"/>
+          <a:ln xmlns:a="http://schemas.openxmlformats.org/drawingml/2006/main" w="0">
+            <a:noFill/>
+            <a:prstDash val="solid"/>
+          </a:ln>
+        </p:spPr>
+        <p:txBody>
+          <a:bodyPr xmlns:a="http://schemas.openxmlformats.org/drawingml/2006/main"/>
+          <a:lstStyle xmlns:a="http://schemas.openxmlformats.org/drawingml/2006/main"/>
+          <a:p xmlns:a="http://schemas.openxmlformats.org/drawingml/2006/main">
+            <a:pPr>
+              <a:defRPr sz="675" b="1">
+                <a:solidFill>
+                  <a:srgbClr val="1D70B8"/>
+                </a:solidFill>
+              </a:defRPr>
+            </a:pPr>
+            <a:r>
+              <a:rPr sz="675" b="1">
+                <a:solidFill>
+                  <a:srgbClr val="1D70B8"/>
+                </a:solidFill>
+              </a:rPr>
+              <a:t>主规模</a:t>
+            </a:r>
+          </a:p>
+        </p:txBody>
+      </p:sp>
+      <p:sp>
+        <p:nvSpPr>
+          <p:cNvPr id="62" name="">
+            <a:extLst xmlns:a="http://schemas.openxmlformats.org/drawingml/2006/main">
+              <a:ext uri="{FF2B5EF4-FFF2-40B4-BE49-F238E27FC236}">
+                <a16:creationId xmlns:a16="http://schemas.microsoft.com/office/drawing/2014/main" id="{0943CDA2-A69C-4040-A2E2-36B026A787B7}"/>
+              </a:ext>
+            </a:extLst>
+          </p:cNvPr>
+          <p:cNvSpPr>
+            <a:spLocks xmlns:a="http://schemas.openxmlformats.org/drawingml/2006/main" noGrp="1"/>
+          </p:cNvSpPr>
+          <p:nvPr/>
+        </p:nvSpPr>
+        <p:spPr>
+          <a:xfrm xmlns:a="http://schemas.openxmlformats.org/drawingml/2006/main">
+            <a:off x="857250" y="2638425"/>
+            <a:ext cx="3048000" cy="352425"/>
+          </a:xfrm>
+          <a:prstGeom xmlns:a="http://schemas.openxmlformats.org/drawingml/2006/main" prst="rect">
+            <a:avLst/>
+          </a:prstGeom>
+          <a:noFill xmlns:a="http://schemas.openxmlformats.org/drawingml/2006/main"/>
+          <a:ln xmlns:a="http://schemas.openxmlformats.org/drawingml/2006/main" w="0">
+            <a:noFill/>
+            <a:prstDash val="solid"/>
+          </a:ln>
+        </p:spPr>
+        <p:txBody>
+          <a:bodyPr xmlns:a="http://schemas.openxmlformats.org/drawingml/2006/main"/>
+          <a:lstStyle xmlns:a="http://schemas.openxmlformats.org/drawingml/2006/main"/>
+          <a:p xmlns:a="http://schemas.openxmlformats.org/drawingml/2006/main">
+            <a:pPr>
+              <a:defRPr sz="750" b="1">
+                <a:solidFill>
+                  <a:srgbClr val="132F4C"/>
+                </a:solidFill>
+              </a:defRPr>
+            </a:pPr>
+            <a:r>
+              <a:rPr sz="750" b="1">
+                <a:solidFill>
+                  <a:srgbClr val="132F4C"/>
+                </a:solidFill>
+              </a:rPr>
+              <a:t>24 scenarios</a:t>
+            </a:r>
+          </a:p>
+          <a:p xmlns:a="http://schemas.openxmlformats.org/drawingml/2006/main">
+            <a:pPr>
+              <a:defRPr sz="750" b="1">
+                <a:solidFill>
+                  <a:srgbClr val="132F4C"/>
+                </a:solidFill>
+              </a:defRPr>
+            </a:pPr>
+            <a:r>
+              <a:rPr sz="750" b="1">
+                <a:solidFill>
+                  <a:srgbClr val="132F4C"/>
+                </a:solidFill>
+              </a:rPr>
+              <a:t>48 logical/actual executions</a:t>
+            </a:r>
+          </a:p>
+        </p:txBody>
+      </p:sp>
+      <p:sp>
+        <p:nvSpPr>
+          <p:cNvPr id="63" name="">
+            <a:extLst xmlns:a="http://schemas.openxmlformats.org/drawingml/2006/main">
+              <a:ext uri="{FF2B5EF4-FFF2-40B4-BE49-F238E27FC236}">
+                <a16:creationId xmlns:a16="http://schemas.microsoft.com/office/drawing/2014/main" id="{899E99FB-45A8-4EE4-B2C9-94A4A756D389}"/>
+              </a:ext>
+            </a:extLst>
+          </p:cNvPr>
+          <p:cNvSpPr>
+            <a:spLocks xmlns:a="http://schemas.openxmlformats.org/drawingml/2006/main" noGrp="1"/>
+          </p:cNvSpPr>
+          <p:nvPr/>
+        </p:nvSpPr>
+        <p:spPr>
+          <a:xfrm xmlns:a="http://schemas.openxmlformats.org/drawingml/2006/main">
+            <a:off x="857250" y="3048000"/>
+            <a:ext cx="3048000" cy="161925"/>
+          </a:xfrm>
+          <a:prstGeom xmlns:a="http://schemas.openxmlformats.org/drawingml/2006/main" prst="rect">
+            <a:avLst/>
+          </a:prstGeom>
+          <a:noFill xmlns:a="http://schemas.openxmlformats.org/drawingml/2006/main"/>
+          <a:ln xmlns:a="http://schemas.openxmlformats.org/drawingml/2006/main" w="0">
+            <a:noFill/>
+            <a:prstDash val="solid"/>
+          </a:ln>
+        </p:spPr>
+        <p:txBody>
+          <a:bodyPr xmlns:a="http://schemas.openxmlformats.org/drawingml/2006/main"/>
+          <a:lstStyle xmlns:a="http://schemas.openxmlformats.org/drawingml/2006/main"/>
           <a:p xmlns:a="http://schemas.openxmlformats.org/drawingml/2006/main">
             <a:pPr>
               <a:defRPr sz="675">
                 <a:solidFill>
+                  <a:srgbClr val="486581"/>
+                </a:solidFill>
+              </a:defRPr>
+            </a:pPr>
+            <a:r>
+              <a:rPr sz="675">
+                <a:solidFill>
+                  <a:srgbClr val="486581"/>
+                </a:solidFill>
+              </a:rPr>
+              <a:t>基础接受性 · 48 actual executions</a:t>
+            </a:r>
+          </a:p>
+        </p:txBody>
+      </p:sp>
+      <p:sp>
+        <p:nvSpPr>
+          <p:cNvPr id="64" name="">
+            <a:extLst xmlns:a="http://schemas.openxmlformats.org/drawingml/2006/main">
+              <a:ext uri="{FF2B5EF4-FFF2-40B4-BE49-F238E27FC236}">
+                <a16:creationId xmlns:a16="http://schemas.microsoft.com/office/drawing/2014/main" id="{436AAAD1-77F7-48BB-A0DC-16DE992ED9CF}"/>
+              </a:ext>
+            </a:extLst>
+          </p:cNvPr>
+          <p:cNvSpPr>
+            <a:spLocks xmlns:a="http://schemas.openxmlformats.org/drawingml/2006/main" noGrp="1"/>
+          </p:cNvSpPr>
+          <p:nvPr/>
+        </p:nvSpPr>
+        <p:spPr>
+          <a:xfrm xmlns:a="http://schemas.openxmlformats.org/drawingml/2006/main">
+            <a:off x="4381500" y="1762125"/>
+            <a:ext cx="3429000" cy="1524000"/>
+          </a:xfrm>
+          <a:prstGeom xmlns:a="http://schemas.openxmlformats.org/drawingml/2006/main" prst="rect">
+            <a:avLst/>
+          </a:prstGeom>
+          <a:solidFill xmlns:a="http://schemas.openxmlformats.org/drawingml/2006/main">
+            <a:srgbClr val="EAF4FC"/>
+          </a:solidFill>
+          <a:ln xmlns:a="http://schemas.openxmlformats.org/drawingml/2006/main" w="9525">
+            <a:solidFill>
+              <a:srgbClr val="C7DDF0"/>
+            </a:solidFill>
+            <a:prstDash val="solid"/>
+          </a:ln>
+        </p:spPr>
+      </p:sp>
+      <p:sp>
+        <p:nvSpPr>
+          <p:cNvPr id="65" name="">
+            <a:extLst xmlns:a="http://schemas.openxmlformats.org/drawingml/2006/main">
+              <a:ext uri="{FF2B5EF4-FFF2-40B4-BE49-F238E27FC236}">
+                <a16:creationId xmlns:a16="http://schemas.microsoft.com/office/drawing/2014/main" id="{CF35DF7E-DF21-4D71-ABF2-D3F7EDB892EF}"/>
+              </a:ext>
+            </a:extLst>
+          </p:cNvPr>
+          <p:cNvSpPr>
+            <a:spLocks xmlns:a="http://schemas.openxmlformats.org/drawingml/2006/main" noGrp="1"/>
+          </p:cNvSpPr>
+          <p:nvPr/>
+        </p:nvSpPr>
+        <p:spPr>
+          <a:xfrm xmlns:a="http://schemas.openxmlformats.org/drawingml/2006/main">
+            <a:off x="4381500" y="1762125"/>
+            <a:ext cx="66675" cy="1524000"/>
+          </a:xfrm>
+          <a:prstGeom xmlns:a="http://schemas.openxmlformats.org/drawingml/2006/main" prst="rect">
+            <a:avLst/>
+          </a:prstGeom>
+          <a:solidFill xmlns:a="http://schemas.openxmlformats.org/drawingml/2006/main">
+            <a:srgbClr val="1D70B8"/>
+          </a:solidFill>
+          <a:ln xmlns:a="http://schemas.openxmlformats.org/drawingml/2006/main" w="9525">
+            <a:solidFill>
+              <a:srgbClr val="1D70B8"/>
+            </a:solidFill>
+            <a:prstDash val="solid"/>
+          </a:ln>
+        </p:spPr>
+      </p:sp>
+      <p:sp>
+        <p:nvSpPr>
+          <p:cNvPr id="66" name="">
+            <a:extLst xmlns:a="http://schemas.openxmlformats.org/drawingml/2006/main">
+              <a:ext uri="{FF2B5EF4-FFF2-40B4-BE49-F238E27FC236}">
+                <a16:creationId xmlns:a16="http://schemas.microsoft.com/office/drawing/2014/main" id="{5762A65D-8AC5-4209-A8FD-5F124CF20948}"/>
+              </a:ext>
+            </a:extLst>
+          </p:cNvPr>
+          <p:cNvSpPr>
+            <a:spLocks xmlns:a="http://schemas.openxmlformats.org/drawingml/2006/main" noGrp="1"/>
+          </p:cNvSpPr>
+          <p:nvPr/>
+        </p:nvSpPr>
+        <p:spPr>
+          <a:xfrm xmlns:a="http://schemas.openxmlformats.org/drawingml/2006/main">
+            <a:off x="4572000" y="1914525"/>
+            <a:ext cx="323850" cy="285750"/>
+          </a:xfrm>
+          <a:prstGeom xmlns:a="http://schemas.openxmlformats.org/drawingml/2006/main" prst="rect">
+            <a:avLst/>
+          </a:prstGeom>
+          <a:noFill xmlns:a="http://schemas.openxmlformats.org/drawingml/2006/main"/>
+          <a:ln xmlns:a="http://schemas.openxmlformats.org/drawingml/2006/main" w="0">
+            <a:noFill/>
+            <a:prstDash val="solid"/>
+          </a:ln>
+        </p:spPr>
+        <p:txBody>
+          <a:bodyPr xmlns:a="http://schemas.openxmlformats.org/drawingml/2006/main"/>
+          <a:lstStyle xmlns:a="http://schemas.openxmlformats.org/drawingml/2006/main"/>
+          <a:p xmlns:a="http://schemas.openxmlformats.org/drawingml/2006/main">
+            <a:pPr>
+              <a:defRPr sz="1725" b="1">
+                <a:solidFill>
+                  <a:srgbClr val="1D70B8"/>
+                </a:solidFill>
+              </a:defRPr>
+            </a:pPr>
+            <a:r>
+              <a:rPr sz="1725" b="1">
+                <a:solidFill>
+                  <a:srgbClr val="1D70B8"/>
+                </a:solidFill>
+              </a:rPr>
+              <a:t>B</a:t>
+            </a:r>
+          </a:p>
+        </p:txBody>
+      </p:sp>
+      <p:sp>
+        <p:nvSpPr>
+          <p:cNvPr id="67" name="">
+            <a:extLst xmlns:a="http://schemas.openxmlformats.org/drawingml/2006/main">
+              <a:ext uri="{FF2B5EF4-FFF2-40B4-BE49-F238E27FC236}">
+                <a16:creationId xmlns:a16="http://schemas.microsoft.com/office/drawing/2014/main" id="{019D2654-8606-41D5-8E58-A4174F4E7EF0}"/>
+              </a:ext>
+            </a:extLst>
+          </p:cNvPr>
+          <p:cNvSpPr>
+            <a:spLocks xmlns:a="http://schemas.openxmlformats.org/drawingml/2006/main" noGrp="1"/>
+          </p:cNvSpPr>
+          <p:nvPr/>
+        </p:nvSpPr>
+        <p:spPr>
+          <a:xfrm xmlns:a="http://schemas.openxmlformats.org/drawingml/2006/main">
+            <a:off x="4991100" y="1924050"/>
+            <a:ext cx="1257300" cy="247650"/>
+          </a:xfrm>
+          <a:prstGeom xmlns:a="http://schemas.openxmlformats.org/drawingml/2006/main" prst="rect">
+            <a:avLst/>
+          </a:prstGeom>
+          <a:noFill xmlns:a="http://schemas.openxmlformats.org/drawingml/2006/main"/>
+          <a:ln xmlns:a="http://schemas.openxmlformats.org/drawingml/2006/main" w="0">
+            <a:noFill/>
+            <a:prstDash val="solid"/>
+          </a:ln>
+        </p:spPr>
+        <p:txBody>
+          <a:bodyPr xmlns:a="http://schemas.openxmlformats.org/drawingml/2006/main"/>
+          <a:lstStyle xmlns:a="http://schemas.openxmlformats.org/drawingml/2006/main"/>
+          <a:p xmlns:a="http://schemas.openxmlformats.org/drawingml/2006/main">
+            <a:pPr>
+              <a:defRPr sz="1200" b="1">
+                <a:solidFill>
+                  <a:srgbClr val="0F3456"/>
+                </a:solidFill>
+              </a:defRPr>
+            </a:pPr>
+            <a:r>
+              <a:rPr sz="1200" b="1">
+                <a:solidFill>
+                  <a:srgbClr val="0F3456"/>
+                </a:solidFill>
+              </a:rPr>
+              <a:t>边界</a:t>
+            </a:r>
+          </a:p>
+        </p:txBody>
+      </p:sp>
+      <p:sp>
+        <p:nvSpPr>
+          <p:cNvPr id="68" name="">
+            <a:extLst xmlns:a="http://schemas.openxmlformats.org/drawingml/2006/main">
+              <a:ext uri="{FF2B5EF4-FFF2-40B4-BE49-F238E27FC236}">
+                <a16:creationId xmlns:a16="http://schemas.microsoft.com/office/drawing/2014/main" id="{874CD29A-5C83-40B5-9474-79DA1BC49E7E}"/>
+              </a:ext>
+            </a:extLst>
+          </p:cNvPr>
+          <p:cNvSpPr>
+            <a:spLocks xmlns:a="http://schemas.openxmlformats.org/drawingml/2006/main" noGrp="1"/>
+          </p:cNvSpPr>
+          <p:nvPr/>
+        </p:nvSpPr>
+        <p:spPr>
+          <a:xfrm xmlns:a="http://schemas.openxmlformats.org/drawingml/2006/main">
+            <a:off x="4572000" y="2228850"/>
+            <a:ext cx="3048000" cy="171450"/>
+          </a:xfrm>
+          <a:prstGeom xmlns:a="http://schemas.openxmlformats.org/drawingml/2006/main" prst="rect">
+            <a:avLst/>
+          </a:prstGeom>
+          <a:noFill xmlns:a="http://schemas.openxmlformats.org/drawingml/2006/main"/>
+          <a:ln xmlns:a="http://schemas.openxmlformats.org/drawingml/2006/main" w="0">
+            <a:noFill/>
+            <a:prstDash val="solid"/>
+          </a:ln>
+        </p:spPr>
+        <p:txBody>
+          <a:bodyPr xmlns:a="http://schemas.openxmlformats.org/drawingml/2006/main"/>
+          <a:lstStyle xmlns:a="http://schemas.openxmlformats.org/drawingml/2006/main"/>
+          <a:p xmlns:a="http://schemas.openxmlformats.org/drawingml/2006/main">
+            <a:pPr>
+              <a:defRPr sz="750">
+                <a:solidFill>
                   <a:srgbClr val="5B7190"/>
                 </a:solidFill>
               </a:defRPr>
             </a:pPr>
             <a:r>
-              <a:rPr sz="675">
+              <a:rPr sz="750">
                 <a:solidFill>
                   <a:srgbClr val="5B7190"/>
                 </a:solidFill>
               </a:rPr>
-              <a:t>48 logical / actual</a:t>
-            </a:r>
-          </a:p>
-        </p:txBody>
-      </p:sp>
-      <p:sp>
-        <p:nvSpPr>
-          <p:cNvPr id="45" name="">
-            <a:extLst xmlns:a="http://schemas.openxmlformats.org/drawingml/2006/main">
-              <a:ext uri="{FF2B5EF4-FFF2-40B4-BE49-F238E27FC236}">
-                <a16:creationId xmlns:a16="http://schemas.microsoft.com/office/drawing/2014/main" id="{79639CEE-E719-4EFF-915F-5FF406000AEF}"/>
-              </a:ext>
-            </a:extLst>
-          </p:cNvPr>
-          <p:cNvSpPr>
-            <a:spLocks xmlns:a="http://schemas.openxmlformats.org/drawingml/2006/main" noGrp="1"/>
-          </p:cNvSpPr>
-          <p:nvPr/>
-        </p:nvSpPr>
-        <p:spPr>
-          <a:xfrm xmlns:a="http://schemas.openxmlformats.org/drawingml/2006/main">
-            <a:off x="2486025" y="3448050"/>
-            <a:ext cx="1476375" cy="438150"/>
+              <a:t>物理/经济边界扫描</a:t>
+            </a:r>
+          </a:p>
+        </p:txBody>
+      </p:sp>
+      <p:sp>
+        <p:nvSpPr>
+          <p:cNvPr id="69" name="">
+            <a:extLst xmlns:a="http://schemas.openxmlformats.org/drawingml/2006/main">
+              <a:ext uri="{FF2B5EF4-FFF2-40B4-BE49-F238E27FC236}">
+                <a16:creationId xmlns:a16="http://schemas.microsoft.com/office/drawing/2014/main" id="{485E12DB-98AA-461E-982D-28449E5F79ED}"/>
+              </a:ext>
+            </a:extLst>
+          </p:cNvPr>
+          <p:cNvSpPr>
+            <a:spLocks xmlns:a="http://schemas.openxmlformats.org/drawingml/2006/main" noGrp="1"/>
+          </p:cNvSpPr>
+          <p:nvPr/>
+        </p:nvSpPr>
+        <p:spPr>
+          <a:xfrm xmlns:a="http://schemas.openxmlformats.org/drawingml/2006/main">
+            <a:off x="4572000" y="2486025"/>
+            <a:ext cx="762000" cy="152400"/>
+          </a:xfrm>
+          <a:prstGeom xmlns:a="http://schemas.openxmlformats.org/drawingml/2006/main" prst="rect">
+            <a:avLst/>
+          </a:prstGeom>
+          <a:noFill xmlns:a="http://schemas.openxmlformats.org/drawingml/2006/main"/>
+          <a:ln xmlns:a="http://schemas.openxmlformats.org/drawingml/2006/main" w="0">
+            <a:noFill/>
+            <a:prstDash val="solid"/>
+          </a:ln>
+        </p:spPr>
+        <p:txBody>
+          <a:bodyPr xmlns:a="http://schemas.openxmlformats.org/drawingml/2006/main"/>
+          <a:lstStyle xmlns:a="http://schemas.openxmlformats.org/drawingml/2006/main"/>
+          <a:p xmlns:a="http://schemas.openxmlformats.org/drawingml/2006/main">
+            <a:pPr>
+              <a:defRPr sz="675" b="1">
+                <a:solidFill>
+                  <a:srgbClr val="1D70B8"/>
+                </a:solidFill>
+              </a:defRPr>
+            </a:pPr>
+            <a:r>
+              <a:rPr sz="675" b="1">
+                <a:solidFill>
+                  <a:srgbClr val="1D70B8"/>
+                </a:solidFill>
+              </a:rPr>
+              <a:t>主规模</a:t>
+            </a:r>
+          </a:p>
+        </p:txBody>
+      </p:sp>
+      <p:sp>
+        <p:nvSpPr>
+          <p:cNvPr id="70" name="">
+            <a:extLst xmlns:a="http://schemas.openxmlformats.org/drawingml/2006/main">
+              <a:ext uri="{FF2B5EF4-FFF2-40B4-BE49-F238E27FC236}">
+                <a16:creationId xmlns:a16="http://schemas.microsoft.com/office/drawing/2014/main" id="{0BEAE68C-B8B0-44F5-BE25-575FF67A3764}"/>
+              </a:ext>
+            </a:extLst>
+          </p:cNvPr>
+          <p:cNvSpPr>
+            <a:spLocks xmlns:a="http://schemas.openxmlformats.org/drawingml/2006/main" noGrp="1"/>
+          </p:cNvSpPr>
+          <p:nvPr/>
+        </p:nvSpPr>
+        <p:spPr>
+          <a:xfrm xmlns:a="http://schemas.openxmlformats.org/drawingml/2006/main">
+            <a:off x="4572000" y="2638425"/>
+            <a:ext cx="3048000" cy="352425"/>
+          </a:xfrm>
+          <a:prstGeom xmlns:a="http://schemas.openxmlformats.org/drawingml/2006/main" prst="rect">
+            <a:avLst/>
+          </a:prstGeom>
+          <a:noFill xmlns:a="http://schemas.openxmlformats.org/drawingml/2006/main"/>
+          <a:ln xmlns:a="http://schemas.openxmlformats.org/drawingml/2006/main" w="0">
+            <a:noFill/>
+            <a:prstDash val="solid"/>
+          </a:ln>
+        </p:spPr>
+        <p:txBody>
+          <a:bodyPr xmlns:a="http://schemas.openxmlformats.org/drawingml/2006/main"/>
+          <a:lstStyle xmlns:a="http://schemas.openxmlformats.org/drawingml/2006/main"/>
+          <a:p xmlns:a="http://schemas.openxmlformats.org/drawingml/2006/main">
+            <a:pPr>
+              <a:defRPr sz="750" b="1">
+                <a:solidFill>
+                  <a:srgbClr val="132F4C"/>
+                </a:solidFill>
+              </a:defRPr>
+            </a:pPr>
+            <a:r>
+              <a:rPr sz="750" b="1">
+                <a:solidFill>
+                  <a:srgbClr val="132F4C"/>
+                </a:solidFill>
+              </a:rPr>
+              <a:t>72 scenarios</a:t>
+            </a:r>
+          </a:p>
+          <a:p xmlns:a="http://schemas.openxmlformats.org/drawingml/2006/main">
+            <a:pPr>
+              <a:defRPr sz="750" b="1">
+                <a:solidFill>
+                  <a:srgbClr val="132F4C"/>
+                </a:solidFill>
+              </a:defRPr>
+            </a:pPr>
+            <a:r>
+              <a:rPr sz="750" b="1">
+                <a:solidFill>
+                  <a:srgbClr val="132F4C"/>
+                </a:solidFill>
+              </a:rPr>
+              <a:t>144 logical paths · 102 unique actual executions</a:t>
+            </a:r>
+          </a:p>
+        </p:txBody>
+      </p:sp>
+      <p:sp>
+        <p:nvSpPr>
+          <p:cNvPr id="71" name="">
+            <a:extLst xmlns:a="http://schemas.openxmlformats.org/drawingml/2006/main">
+              <a:ext uri="{FF2B5EF4-FFF2-40B4-BE49-F238E27FC236}">
+                <a16:creationId xmlns:a16="http://schemas.microsoft.com/office/drawing/2014/main" id="{5B37491E-204D-4B85-AFEB-398F70E9C41E}"/>
+              </a:ext>
+            </a:extLst>
+          </p:cNvPr>
+          <p:cNvSpPr>
+            <a:spLocks xmlns:a="http://schemas.openxmlformats.org/drawingml/2006/main" noGrp="1"/>
+          </p:cNvSpPr>
+          <p:nvPr/>
+        </p:nvSpPr>
+        <p:spPr>
+          <a:xfrm xmlns:a="http://schemas.openxmlformats.org/drawingml/2006/main">
+            <a:off x="4572000" y="3048000"/>
+            <a:ext cx="3048000" cy="161925"/>
           </a:xfrm>
           <a:prstGeom xmlns:a="http://schemas.openxmlformats.org/drawingml/2006/main" prst="rect">
             <a:avLst/>
@@ -14633,56 +15879,755 @@
             <a:pPr>
               <a:defRPr sz="675">
                 <a:solidFill>
+                  <a:srgbClr val="486581"/>
+                </a:solidFill>
+              </a:defRPr>
+            </a:pPr>
+            <a:r>
+              <a:rPr sz="675">
+                <a:solidFill>
+                  <a:srgbClr val="486581"/>
+                </a:solidFill>
+              </a:rPr>
+              <a:t>B4 accounting-only reuse is explicit</a:t>
+            </a:r>
+          </a:p>
+        </p:txBody>
+      </p:sp>
+      <p:sp>
+        <p:nvSpPr>
+          <p:cNvPr id="72" name="">
+            <a:extLst xmlns:a="http://schemas.openxmlformats.org/drawingml/2006/main">
+              <a:ext uri="{FF2B5EF4-FFF2-40B4-BE49-F238E27FC236}">
+                <a16:creationId xmlns:a16="http://schemas.microsoft.com/office/drawing/2014/main" id="{3A3DC7EF-4E86-4AFF-A851-94C76A642FB1}"/>
+              </a:ext>
+            </a:extLst>
+          </p:cNvPr>
+          <p:cNvSpPr>
+            <a:spLocks xmlns:a="http://schemas.openxmlformats.org/drawingml/2006/main" noGrp="1"/>
+          </p:cNvSpPr>
+          <p:nvPr/>
+        </p:nvSpPr>
+        <p:spPr>
+          <a:xfrm xmlns:a="http://schemas.openxmlformats.org/drawingml/2006/main">
+            <a:off x="8096250" y="1762125"/>
+            <a:ext cx="3429000" cy="1524000"/>
+          </a:xfrm>
+          <a:prstGeom xmlns:a="http://schemas.openxmlformats.org/drawingml/2006/main" prst="rect">
+            <a:avLst/>
+          </a:prstGeom>
+          <a:solidFill xmlns:a="http://schemas.openxmlformats.org/drawingml/2006/main">
+            <a:srgbClr val="EAF4FC"/>
+          </a:solidFill>
+          <a:ln xmlns:a="http://schemas.openxmlformats.org/drawingml/2006/main" w="9525">
+            <a:solidFill>
+              <a:srgbClr val="C7DDF0"/>
+            </a:solidFill>
+            <a:prstDash val="solid"/>
+          </a:ln>
+        </p:spPr>
+      </p:sp>
+      <p:sp>
+        <p:nvSpPr>
+          <p:cNvPr id="73" name="">
+            <a:extLst xmlns:a="http://schemas.openxmlformats.org/drawingml/2006/main">
+              <a:ext uri="{FF2B5EF4-FFF2-40B4-BE49-F238E27FC236}">
+                <a16:creationId xmlns:a16="http://schemas.microsoft.com/office/drawing/2014/main" id="{2E2A1577-1E6F-4AEC-837F-9D391FC7E749}"/>
+              </a:ext>
+            </a:extLst>
+          </p:cNvPr>
+          <p:cNvSpPr>
+            <a:spLocks xmlns:a="http://schemas.openxmlformats.org/drawingml/2006/main" noGrp="1"/>
+          </p:cNvSpPr>
+          <p:nvPr/>
+        </p:nvSpPr>
+        <p:spPr>
+          <a:xfrm xmlns:a="http://schemas.openxmlformats.org/drawingml/2006/main">
+            <a:off x="8096250" y="1762125"/>
+            <a:ext cx="66675" cy="1524000"/>
+          </a:xfrm>
+          <a:prstGeom xmlns:a="http://schemas.openxmlformats.org/drawingml/2006/main" prst="rect">
+            <a:avLst/>
+          </a:prstGeom>
+          <a:solidFill xmlns:a="http://schemas.openxmlformats.org/drawingml/2006/main">
+            <a:srgbClr val="1D70B8"/>
+          </a:solidFill>
+          <a:ln xmlns:a="http://schemas.openxmlformats.org/drawingml/2006/main" w="9525">
+            <a:solidFill>
+              <a:srgbClr val="1D70B8"/>
+            </a:solidFill>
+            <a:prstDash val="solid"/>
+          </a:ln>
+        </p:spPr>
+      </p:sp>
+      <p:sp>
+        <p:nvSpPr>
+          <p:cNvPr id="74" name="">
+            <a:extLst xmlns:a="http://schemas.openxmlformats.org/drawingml/2006/main">
+              <a:ext uri="{FF2B5EF4-FFF2-40B4-BE49-F238E27FC236}">
+                <a16:creationId xmlns:a16="http://schemas.microsoft.com/office/drawing/2014/main" id="{D7694823-152A-4D90-AAB0-C17A4EBA5720}"/>
+              </a:ext>
+            </a:extLst>
+          </p:cNvPr>
+          <p:cNvSpPr>
+            <a:spLocks xmlns:a="http://schemas.openxmlformats.org/drawingml/2006/main" noGrp="1"/>
+          </p:cNvSpPr>
+          <p:nvPr/>
+        </p:nvSpPr>
+        <p:spPr>
+          <a:xfrm xmlns:a="http://schemas.openxmlformats.org/drawingml/2006/main">
+            <a:off x="8286750" y="1914525"/>
+            <a:ext cx="323850" cy="285750"/>
+          </a:xfrm>
+          <a:prstGeom xmlns:a="http://schemas.openxmlformats.org/drawingml/2006/main" prst="rect">
+            <a:avLst/>
+          </a:prstGeom>
+          <a:noFill xmlns:a="http://schemas.openxmlformats.org/drawingml/2006/main"/>
+          <a:ln xmlns:a="http://schemas.openxmlformats.org/drawingml/2006/main" w="0">
+            <a:noFill/>
+            <a:prstDash val="solid"/>
+          </a:ln>
+        </p:spPr>
+        <p:txBody>
+          <a:bodyPr xmlns:a="http://schemas.openxmlformats.org/drawingml/2006/main"/>
+          <a:lstStyle xmlns:a="http://schemas.openxmlformats.org/drawingml/2006/main"/>
+          <a:p xmlns:a="http://schemas.openxmlformats.org/drawingml/2006/main">
+            <a:pPr>
+              <a:defRPr sz="1725" b="1">
+                <a:solidFill>
+                  <a:srgbClr val="1D70B8"/>
+                </a:solidFill>
+              </a:defRPr>
+            </a:pPr>
+            <a:r>
+              <a:rPr sz="1725" b="1">
+                <a:solidFill>
+                  <a:srgbClr val="1D70B8"/>
+                </a:solidFill>
+              </a:rPr>
+              <a:t>C</a:t>
+            </a:r>
+          </a:p>
+        </p:txBody>
+      </p:sp>
+      <p:sp>
+        <p:nvSpPr>
+          <p:cNvPr id="75" name="">
+            <a:extLst xmlns:a="http://schemas.openxmlformats.org/drawingml/2006/main">
+              <a:ext uri="{FF2B5EF4-FFF2-40B4-BE49-F238E27FC236}">
+                <a16:creationId xmlns:a16="http://schemas.microsoft.com/office/drawing/2014/main" id="{4A7EC2D8-F85A-4FB8-B849-0011B56A9CC7}"/>
+              </a:ext>
+            </a:extLst>
+          </p:cNvPr>
+          <p:cNvSpPr>
+            <a:spLocks xmlns:a="http://schemas.openxmlformats.org/drawingml/2006/main" noGrp="1"/>
+          </p:cNvSpPr>
+          <p:nvPr/>
+        </p:nvSpPr>
+        <p:spPr>
+          <a:xfrm xmlns:a="http://schemas.openxmlformats.org/drawingml/2006/main">
+            <a:off x="8705850" y="1924050"/>
+            <a:ext cx="1257300" cy="247650"/>
+          </a:xfrm>
+          <a:prstGeom xmlns:a="http://schemas.openxmlformats.org/drawingml/2006/main" prst="rect">
+            <a:avLst/>
+          </a:prstGeom>
+          <a:noFill xmlns:a="http://schemas.openxmlformats.org/drawingml/2006/main"/>
+          <a:ln xmlns:a="http://schemas.openxmlformats.org/drawingml/2006/main" w="0">
+            <a:noFill/>
+            <a:prstDash val="solid"/>
+          </a:ln>
+        </p:spPr>
+        <p:txBody>
+          <a:bodyPr xmlns:a="http://schemas.openxmlformats.org/drawingml/2006/main"/>
+          <a:lstStyle xmlns:a="http://schemas.openxmlformats.org/drawingml/2006/main"/>
+          <a:p xmlns:a="http://schemas.openxmlformats.org/drawingml/2006/main">
+            <a:pPr>
+              <a:defRPr sz="1200" b="1">
+                <a:solidFill>
+                  <a:srgbClr val="0F3456"/>
+                </a:solidFill>
+              </a:defRPr>
+            </a:pPr>
+            <a:r>
+              <a:rPr sz="1200" b="1">
+                <a:solidFill>
+                  <a:srgbClr val="0F3456"/>
+                </a:solidFill>
+              </a:rPr>
+              <a:t>单日误差</a:t>
+            </a:r>
+          </a:p>
+        </p:txBody>
+      </p:sp>
+      <p:sp>
+        <p:nvSpPr>
+          <p:cNvPr id="76" name="">
+            <a:extLst xmlns:a="http://schemas.openxmlformats.org/drawingml/2006/main">
+              <a:ext uri="{FF2B5EF4-FFF2-40B4-BE49-F238E27FC236}">
+                <a16:creationId xmlns:a16="http://schemas.microsoft.com/office/drawing/2014/main" id="{49E26404-4B2F-4B41-B40C-807B6FAF238E}"/>
+              </a:ext>
+            </a:extLst>
+          </p:cNvPr>
+          <p:cNvSpPr>
+            <a:spLocks xmlns:a="http://schemas.openxmlformats.org/drawingml/2006/main" noGrp="1"/>
+          </p:cNvSpPr>
+          <p:nvPr/>
+        </p:nvSpPr>
+        <p:spPr>
+          <a:xfrm xmlns:a="http://schemas.openxmlformats.org/drawingml/2006/main">
+            <a:off x="8286750" y="2228850"/>
+            <a:ext cx="3048000" cy="171450"/>
+          </a:xfrm>
+          <a:prstGeom xmlns:a="http://schemas.openxmlformats.org/drawingml/2006/main" prst="rect">
+            <a:avLst/>
+          </a:prstGeom>
+          <a:noFill xmlns:a="http://schemas.openxmlformats.org/drawingml/2006/main"/>
+          <a:ln xmlns:a="http://schemas.openxmlformats.org/drawingml/2006/main" w="0">
+            <a:noFill/>
+            <a:prstDash val="solid"/>
+          </a:ln>
+        </p:spPr>
+        <p:txBody>
+          <a:bodyPr xmlns:a="http://schemas.openxmlformats.org/drawingml/2006/main"/>
+          <a:lstStyle xmlns:a="http://schemas.openxmlformats.org/drawingml/2006/main"/>
+          <a:p xmlns:a="http://schemas.openxmlformats.org/drawingml/2006/main">
+            <a:pPr>
+              <a:defRPr sz="750">
+                <a:solidFill>
                   <a:srgbClr val="5B7190"/>
                 </a:solidFill>
               </a:defRPr>
             </a:pPr>
             <a:r>
-              <a:rPr sz="675">
+              <a:rPr sz="750">
                 <a:solidFill>
                   <a:srgbClr val="5B7190"/>
                 </a:solidFill>
               </a:rPr>
-              <a:t>72 scenarios</a:t>
-            </a:r>
-          </a:p>
+              <a:t>forecast ≠ realized</a:t>
+            </a:r>
+          </a:p>
+        </p:txBody>
+      </p:sp>
+      <p:sp>
+        <p:nvSpPr>
+          <p:cNvPr id="77" name="">
+            <a:extLst xmlns:a="http://schemas.openxmlformats.org/drawingml/2006/main">
+              <a:ext uri="{FF2B5EF4-FFF2-40B4-BE49-F238E27FC236}">
+                <a16:creationId xmlns:a16="http://schemas.microsoft.com/office/drawing/2014/main" id="{AC0001DD-BDC4-4BD2-839A-FAD42AAF3C4D}"/>
+              </a:ext>
+            </a:extLst>
+          </p:cNvPr>
+          <p:cNvSpPr>
+            <a:spLocks xmlns:a="http://schemas.openxmlformats.org/drawingml/2006/main" noGrp="1"/>
+          </p:cNvSpPr>
+          <p:nvPr/>
+        </p:nvSpPr>
+        <p:spPr>
+          <a:xfrm xmlns:a="http://schemas.openxmlformats.org/drawingml/2006/main">
+            <a:off x="8286750" y="2486025"/>
+            <a:ext cx="762000" cy="152400"/>
+          </a:xfrm>
+          <a:prstGeom xmlns:a="http://schemas.openxmlformats.org/drawingml/2006/main" prst="rect">
+            <a:avLst/>
+          </a:prstGeom>
+          <a:noFill xmlns:a="http://schemas.openxmlformats.org/drawingml/2006/main"/>
+          <a:ln xmlns:a="http://schemas.openxmlformats.org/drawingml/2006/main" w="0">
+            <a:noFill/>
+            <a:prstDash val="solid"/>
+          </a:ln>
+        </p:spPr>
+        <p:txBody>
+          <a:bodyPr xmlns:a="http://schemas.openxmlformats.org/drawingml/2006/main"/>
+          <a:lstStyle xmlns:a="http://schemas.openxmlformats.org/drawingml/2006/main"/>
+          <a:p xmlns:a="http://schemas.openxmlformats.org/drawingml/2006/main">
+            <a:pPr>
+              <a:defRPr sz="675" b="1">
+                <a:solidFill>
+                  <a:srgbClr val="1D70B8"/>
+                </a:solidFill>
+              </a:defRPr>
+            </a:pPr>
+            <a:r>
+              <a:rPr sz="675" b="1">
+                <a:solidFill>
+                  <a:srgbClr val="1D70B8"/>
+                </a:solidFill>
+              </a:rPr>
+              <a:t>主规模</a:t>
+            </a:r>
+          </a:p>
+        </p:txBody>
+      </p:sp>
+      <p:sp>
+        <p:nvSpPr>
+          <p:cNvPr id="78" name="">
+            <a:extLst xmlns:a="http://schemas.openxmlformats.org/drawingml/2006/main">
+              <a:ext uri="{FF2B5EF4-FFF2-40B4-BE49-F238E27FC236}">
+                <a16:creationId xmlns:a16="http://schemas.microsoft.com/office/drawing/2014/main" id="{E6E2E890-E1F4-40D6-B491-F5DFC1CF42D9}"/>
+              </a:ext>
+            </a:extLst>
+          </p:cNvPr>
+          <p:cNvSpPr>
+            <a:spLocks xmlns:a="http://schemas.openxmlformats.org/drawingml/2006/main" noGrp="1"/>
+          </p:cNvSpPr>
+          <p:nvPr/>
+        </p:nvSpPr>
+        <p:spPr>
+          <a:xfrm xmlns:a="http://schemas.openxmlformats.org/drawingml/2006/main">
+            <a:off x="8286750" y="2638425"/>
+            <a:ext cx="3048000" cy="352425"/>
+          </a:xfrm>
+          <a:prstGeom xmlns:a="http://schemas.openxmlformats.org/drawingml/2006/main" prst="rect">
+            <a:avLst/>
+          </a:prstGeom>
+          <a:noFill xmlns:a="http://schemas.openxmlformats.org/drawingml/2006/main"/>
+          <a:ln xmlns:a="http://schemas.openxmlformats.org/drawingml/2006/main" w="0">
+            <a:noFill/>
+            <a:prstDash val="solid"/>
+          </a:ln>
+        </p:spPr>
+        <p:txBody>
+          <a:bodyPr xmlns:a="http://schemas.openxmlformats.org/drawingml/2006/main"/>
+          <a:lstStyle xmlns:a="http://schemas.openxmlformats.org/drawingml/2006/main"/>
+          <a:p xmlns:a="http://schemas.openxmlformats.org/drawingml/2006/main">
+            <a:pPr>
+              <a:defRPr sz="750" b="1">
+                <a:solidFill>
+                  <a:srgbClr val="132F4C"/>
+                </a:solidFill>
+              </a:defRPr>
+            </a:pPr>
+            <a:r>
+              <a:rPr sz="750" b="1">
+                <a:solidFill>
+                  <a:srgbClr val="132F4C"/>
+                </a:solidFill>
+              </a:rPr>
+              <a:t>39 scenarios</a:t>
+            </a:r>
+          </a:p>
+          <a:p xmlns:a="http://schemas.openxmlformats.org/drawingml/2006/main">
+            <a:pPr>
+              <a:defRPr sz="750" b="1">
+                <a:solidFill>
+                  <a:srgbClr val="132F4C"/>
+                </a:solidFill>
+              </a:defRPr>
+            </a:pPr>
+            <a:r>
+              <a:rPr sz="750" b="1">
+                <a:solidFill>
+                  <a:srgbClr val="132F4C"/>
+                </a:solidFill>
+              </a:rPr>
+              <a:t>78 independent executions</a:t>
+            </a:r>
+          </a:p>
+        </p:txBody>
+      </p:sp>
+      <p:sp>
+        <p:nvSpPr>
+          <p:cNvPr id="79" name="">
+            <a:extLst xmlns:a="http://schemas.openxmlformats.org/drawingml/2006/main">
+              <a:ext uri="{FF2B5EF4-FFF2-40B4-BE49-F238E27FC236}">
+                <a16:creationId xmlns:a16="http://schemas.microsoft.com/office/drawing/2014/main" id="{34E4B05B-C7D2-4B2E-9C32-BF84D60DA546}"/>
+              </a:ext>
+            </a:extLst>
+          </p:cNvPr>
+          <p:cNvSpPr>
+            <a:spLocks xmlns:a="http://schemas.openxmlformats.org/drawingml/2006/main" noGrp="1"/>
+          </p:cNvSpPr>
+          <p:nvPr/>
+        </p:nvSpPr>
+        <p:spPr>
+          <a:xfrm xmlns:a="http://schemas.openxmlformats.org/drawingml/2006/main">
+            <a:off x="8286750" y="3048000"/>
+            <a:ext cx="3048000" cy="161925"/>
+          </a:xfrm>
+          <a:prstGeom xmlns:a="http://schemas.openxmlformats.org/drawingml/2006/main" prst="rect">
+            <a:avLst/>
+          </a:prstGeom>
+          <a:noFill xmlns:a="http://schemas.openxmlformats.org/drawingml/2006/main"/>
+          <a:ln xmlns:a="http://schemas.openxmlformats.org/drawingml/2006/main" w="0">
+            <a:noFill/>
+            <a:prstDash val="solid"/>
+          </a:ln>
+        </p:spPr>
+        <p:txBody>
+          <a:bodyPr xmlns:a="http://schemas.openxmlformats.org/drawingml/2006/main"/>
+          <a:lstStyle xmlns:a="http://schemas.openxmlformats.org/drawingml/2006/main"/>
           <a:p xmlns:a="http://schemas.openxmlformats.org/drawingml/2006/main">
             <a:pPr>
               <a:defRPr sz="675">
                 <a:solidFill>
+                  <a:srgbClr val="486581"/>
+                </a:solidFill>
+              </a:defRPr>
+            </a:pPr>
+            <a:r>
+              <a:rPr sz="675">
+                <a:solidFill>
+                  <a:srgbClr val="486581"/>
+                </a:solidFill>
+              </a:rPr>
+              <a:t>perfect anchor comparison</a:t>
+            </a:r>
+          </a:p>
+        </p:txBody>
+      </p:sp>
+      <p:sp>
+        <p:nvSpPr>
+          <p:cNvPr id="80" name="">
+            <a:extLst xmlns:a="http://schemas.openxmlformats.org/drawingml/2006/main">
+              <a:ext uri="{FF2B5EF4-FFF2-40B4-BE49-F238E27FC236}">
+                <a16:creationId xmlns:a16="http://schemas.microsoft.com/office/drawing/2014/main" id="{CBC67DB3-D23C-4756-95CD-6469DD7A00F1}"/>
+              </a:ext>
+            </a:extLst>
+          </p:cNvPr>
+          <p:cNvSpPr>
+            <a:spLocks xmlns:a="http://schemas.openxmlformats.org/drawingml/2006/main" noGrp="1"/>
+          </p:cNvSpPr>
+          <p:nvPr/>
+        </p:nvSpPr>
+        <p:spPr>
+          <a:xfrm xmlns:a="http://schemas.openxmlformats.org/drawingml/2006/main">
+            <a:off x="666750" y="3448050"/>
+            <a:ext cx="3429000" cy="1676400"/>
+          </a:xfrm>
+          <a:prstGeom xmlns:a="http://schemas.openxmlformats.org/drawingml/2006/main" prst="rect">
+            <a:avLst/>
+          </a:prstGeom>
+          <a:solidFill xmlns:a="http://schemas.openxmlformats.org/drawingml/2006/main">
+            <a:srgbClr val="F5F0FF"/>
+          </a:solidFill>
+          <a:ln xmlns:a="http://schemas.openxmlformats.org/drawingml/2006/main" w="9525">
+            <a:solidFill>
+              <a:srgbClr val="C7DDF0"/>
+            </a:solidFill>
+            <a:prstDash val="solid"/>
+          </a:ln>
+        </p:spPr>
+      </p:sp>
+      <p:sp>
+        <p:nvSpPr>
+          <p:cNvPr id="81" name="">
+            <a:extLst xmlns:a="http://schemas.openxmlformats.org/drawingml/2006/main">
+              <a:ext uri="{FF2B5EF4-FFF2-40B4-BE49-F238E27FC236}">
+                <a16:creationId xmlns:a16="http://schemas.microsoft.com/office/drawing/2014/main" id="{C33A1157-35D7-409A-B90F-34B75BD75A1A}"/>
+              </a:ext>
+            </a:extLst>
+          </p:cNvPr>
+          <p:cNvSpPr>
+            <a:spLocks xmlns:a="http://schemas.openxmlformats.org/drawingml/2006/main" noGrp="1"/>
+          </p:cNvSpPr>
+          <p:nvPr/>
+        </p:nvSpPr>
+        <p:spPr>
+          <a:xfrm xmlns:a="http://schemas.openxmlformats.org/drawingml/2006/main">
+            <a:off x="666750" y="3448050"/>
+            <a:ext cx="66675" cy="1676400"/>
+          </a:xfrm>
+          <a:prstGeom xmlns:a="http://schemas.openxmlformats.org/drawingml/2006/main" prst="rect">
+            <a:avLst/>
+          </a:prstGeom>
+          <a:solidFill xmlns:a="http://schemas.openxmlformats.org/drawingml/2006/main">
+            <a:srgbClr val="7A5AF8"/>
+          </a:solidFill>
+          <a:ln xmlns:a="http://schemas.openxmlformats.org/drawingml/2006/main" w="9525">
+            <a:solidFill>
+              <a:srgbClr val="7A5AF8"/>
+            </a:solidFill>
+            <a:prstDash val="solid"/>
+          </a:ln>
+        </p:spPr>
+      </p:sp>
+      <p:sp>
+        <p:nvSpPr>
+          <p:cNvPr id="82" name="">
+            <a:extLst xmlns:a="http://schemas.openxmlformats.org/drawingml/2006/main">
+              <a:ext uri="{FF2B5EF4-FFF2-40B4-BE49-F238E27FC236}">
+                <a16:creationId xmlns:a16="http://schemas.microsoft.com/office/drawing/2014/main" id="{7E9ADD94-CBFE-4658-9328-BC56F27630C6}"/>
+              </a:ext>
+            </a:extLst>
+          </p:cNvPr>
+          <p:cNvSpPr>
+            <a:spLocks xmlns:a="http://schemas.openxmlformats.org/drawingml/2006/main" noGrp="1"/>
+          </p:cNvSpPr>
+          <p:nvPr/>
+        </p:nvSpPr>
+        <p:spPr>
+          <a:xfrm xmlns:a="http://schemas.openxmlformats.org/drawingml/2006/main">
+            <a:off x="857250" y="3600450"/>
+            <a:ext cx="323850" cy="285750"/>
+          </a:xfrm>
+          <a:prstGeom xmlns:a="http://schemas.openxmlformats.org/drawingml/2006/main" prst="rect">
+            <a:avLst/>
+          </a:prstGeom>
+          <a:noFill xmlns:a="http://schemas.openxmlformats.org/drawingml/2006/main"/>
+          <a:ln xmlns:a="http://schemas.openxmlformats.org/drawingml/2006/main" w="0">
+            <a:noFill/>
+            <a:prstDash val="solid"/>
+          </a:ln>
+        </p:spPr>
+        <p:txBody>
+          <a:bodyPr xmlns:a="http://schemas.openxmlformats.org/drawingml/2006/main"/>
+          <a:lstStyle xmlns:a="http://schemas.openxmlformats.org/drawingml/2006/main"/>
+          <a:p xmlns:a="http://schemas.openxmlformats.org/drawingml/2006/main">
+            <a:pPr>
+              <a:defRPr sz="1725" b="1">
+                <a:solidFill>
+                  <a:srgbClr val="7A5AF8"/>
+                </a:solidFill>
+              </a:defRPr>
+            </a:pPr>
+            <a:r>
+              <a:rPr sz="1725" b="1">
+                <a:solidFill>
+                  <a:srgbClr val="7A5AF8"/>
+                </a:solidFill>
+              </a:rPr>
+              <a:t>D</a:t>
+            </a:r>
+          </a:p>
+        </p:txBody>
+      </p:sp>
+      <p:sp>
+        <p:nvSpPr>
+          <p:cNvPr id="83" name="">
+            <a:extLst xmlns:a="http://schemas.openxmlformats.org/drawingml/2006/main">
+              <a:ext uri="{FF2B5EF4-FFF2-40B4-BE49-F238E27FC236}">
+                <a16:creationId xmlns:a16="http://schemas.microsoft.com/office/drawing/2014/main" id="{8F916864-A5AC-4685-A901-AA495B33F31D}"/>
+              </a:ext>
+            </a:extLst>
+          </p:cNvPr>
+          <p:cNvSpPr>
+            <a:spLocks xmlns:a="http://schemas.openxmlformats.org/drawingml/2006/main" noGrp="1"/>
+          </p:cNvSpPr>
+          <p:nvPr/>
+        </p:nvSpPr>
+        <p:spPr>
+          <a:xfrm xmlns:a="http://schemas.openxmlformats.org/drawingml/2006/main">
+            <a:off x="1276350" y="3609975"/>
+            <a:ext cx="1257300" cy="247650"/>
+          </a:xfrm>
+          <a:prstGeom xmlns:a="http://schemas.openxmlformats.org/drawingml/2006/main" prst="rect">
+            <a:avLst/>
+          </a:prstGeom>
+          <a:noFill xmlns:a="http://schemas.openxmlformats.org/drawingml/2006/main"/>
+          <a:ln xmlns:a="http://schemas.openxmlformats.org/drawingml/2006/main" w="0">
+            <a:noFill/>
+            <a:prstDash val="solid"/>
+          </a:ln>
+        </p:spPr>
+        <p:txBody>
+          <a:bodyPr xmlns:a="http://schemas.openxmlformats.org/drawingml/2006/main"/>
+          <a:lstStyle xmlns:a="http://schemas.openxmlformats.org/drawingml/2006/main"/>
+          <a:p xmlns:a="http://schemas.openxmlformats.org/drawingml/2006/main">
+            <a:pPr>
+              <a:defRPr sz="1200" b="1">
+                <a:solidFill>
+                  <a:srgbClr val="0F3456"/>
+                </a:solidFill>
+              </a:defRPr>
+            </a:pPr>
+            <a:r>
+              <a:rPr sz="1200" b="1">
+                <a:solidFill>
+                  <a:srgbClr val="0F3456"/>
+                </a:solidFill>
+              </a:rPr>
+              <a:t>多日连续</a:t>
+            </a:r>
+          </a:p>
+        </p:txBody>
+      </p:sp>
+      <p:sp>
+        <p:nvSpPr>
+          <p:cNvPr id="84" name="">
+            <a:extLst xmlns:a="http://schemas.openxmlformats.org/drawingml/2006/main">
+              <a:ext uri="{FF2B5EF4-FFF2-40B4-BE49-F238E27FC236}">
+                <a16:creationId xmlns:a16="http://schemas.microsoft.com/office/drawing/2014/main" id="{D990874D-70DE-4216-9C39-694F913A725A}"/>
+              </a:ext>
+            </a:extLst>
+          </p:cNvPr>
+          <p:cNvSpPr>
+            <a:spLocks xmlns:a="http://schemas.openxmlformats.org/drawingml/2006/main" noGrp="1"/>
+          </p:cNvSpPr>
+          <p:nvPr/>
+        </p:nvSpPr>
+        <p:spPr>
+          <a:xfrm xmlns:a="http://schemas.openxmlformats.org/drawingml/2006/main">
+            <a:off x="857250" y="3914775"/>
+            <a:ext cx="3048000" cy="171450"/>
+          </a:xfrm>
+          <a:prstGeom xmlns:a="http://schemas.openxmlformats.org/drawingml/2006/main" prst="rect">
+            <a:avLst/>
+          </a:prstGeom>
+          <a:noFill xmlns:a="http://schemas.openxmlformats.org/drawingml/2006/main"/>
+          <a:ln xmlns:a="http://schemas.openxmlformats.org/drawingml/2006/main" w="0">
+            <a:noFill/>
+            <a:prstDash val="solid"/>
+          </a:ln>
+        </p:spPr>
+        <p:txBody>
+          <a:bodyPr xmlns:a="http://schemas.openxmlformats.org/drawingml/2006/main"/>
+          <a:lstStyle xmlns:a="http://schemas.openxmlformats.org/drawingml/2006/main"/>
+          <a:p xmlns:a="http://schemas.openxmlformats.org/drawingml/2006/main">
+            <a:pPr>
+              <a:defRPr sz="750">
+                <a:solidFill>
                   <a:srgbClr val="5B7190"/>
                 </a:solidFill>
               </a:defRPr>
             </a:pPr>
             <a:r>
-              <a:rPr sz="675">
+              <a:rPr sz="750">
                 <a:solidFill>
                   <a:srgbClr val="5B7190"/>
                 </a:solidFill>
               </a:rPr>
-              <a:t>144 paths / 102 actual</a:t>
-            </a:r>
-          </a:p>
-        </p:txBody>
-      </p:sp>
-      <p:sp>
-        <p:nvSpPr>
-          <p:cNvPr id="46" name="">
-            <a:extLst xmlns:a="http://schemas.openxmlformats.org/drawingml/2006/main">
-              <a:ext uri="{FF2B5EF4-FFF2-40B4-BE49-F238E27FC236}">
-                <a16:creationId xmlns:a16="http://schemas.microsoft.com/office/drawing/2014/main" id="{A04714EC-E29F-4179-AC35-52A8D9DA635C}"/>
-              </a:ext>
-            </a:extLst>
-          </p:cNvPr>
-          <p:cNvSpPr>
-            <a:spLocks xmlns:a="http://schemas.openxmlformats.org/drawingml/2006/main" noGrp="1"/>
-          </p:cNvSpPr>
-          <p:nvPr/>
-        </p:nvSpPr>
-        <p:spPr>
-          <a:xfrm xmlns:a="http://schemas.openxmlformats.org/drawingml/2006/main">
-            <a:off x="4257675" y="3448050"/>
-            <a:ext cx="1476375" cy="438150"/>
+              <a:t>SOC carry 与账务连续</a:t>
+            </a:r>
+          </a:p>
+        </p:txBody>
+      </p:sp>
+      <p:sp>
+        <p:nvSpPr>
+          <p:cNvPr id="85" name="">
+            <a:extLst xmlns:a="http://schemas.openxmlformats.org/drawingml/2006/main">
+              <a:ext uri="{FF2B5EF4-FFF2-40B4-BE49-F238E27FC236}">
+                <a16:creationId xmlns:a16="http://schemas.microsoft.com/office/drawing/2014/main" id="{D3D36DA6-C702-4308-8CBC-8864F136DC38}"/>
+              </a:ext>
+            </a:extLst>
+          </p:cNvPr>
+          <p:cNvSpPr>
+            <a:spLocks xmlns:a="http://schemas.openxmlformats.org/drawingml/2006/main" noGrp="1"/>
+          </p:cNvSpPr>
+          <p:nvPr/>
+        </p:nvSpPr>
+        <p:spPr>
+          <a:xfrm xmlns:a="http://schemas.openxmlformats.org/drawingml/2006/main">
+            <a:off x="857250" y="4171950"/>
+            <a:ext cx="762000" cy="152400"/>
+          </a:xfrm>
+          <a:prstGeom xmlns:a="http://schemas.openxmlformats.org/drawingml/2006/main" prst="rect">
+            <a:avLst/>
+          </a:prstGeom>
+          <a:noFill xmlns:a="http://schemas.openxmlformats.org/drawingml/2006/main"/>
+          <a:ln xmlns:a="http://schemas.openxmlformats.org/drawingml/2006/main" w="0">
+            <a:noFill/>
+            <a:prstDash val="solid"/>
+          </a:ln>
+        </p:spPr>
+        <p:txBody>
+          <a:bodyPr xmlns:a="http://schemas.openxmlformats.org/drawingml/2006/main"/>
+          <a:lstStyle xmlns:a="http://schemas.openxmlformats.org/drawingml/2006/main"/>
+          <a:p xmlns:a="http://schemas.openxmlformats.org/drawingml/2006/main">
+            <a:pPr>
+              <a:defRPr sz="675" b="1">
+                <a:solidFill>
+                  <a:srgbClr val="7A5AF8"/>
+                </a:solidFill>
+              </a:defRPr>
+            </a:pPr>
+            <a:r>
+              <a:rPr sz="675" b="1">
+                <a:solidFill>
+                  <a:srgbClr val="7A5AF8"/>
+                </a:solidFill>
+              </a:rPr>
+              <a:t>主规模</a:t>
+            </a:r>
+          </a:p>
+        </p:txBody>
+      </p:sp>
+      <p:sp>
+        <p:nvSpPr>
+          <p:cNvPr id="86" name="">
+            <a:extLst xmlns:a="http://schemas.openxmlformats.org/drawingml/2006/main">
+              <a:ext uri="{FF2B5EF4-FFF2-40B4-BE49-F238E27FC236}">
+                <a16:creationId xmlns:a16="http://schemas.microsoft.com/office/drawing/2014/main" id="{F67B5601-90B0-4D06-8F4E-E4F3341E77B8}"/>
+              </a:ext>
+            </a:extLst>
+          </p:cNvPr>
+          <p:cNvSpPr>
+            <a:spLocks xmlns:a="http://schemas.openxmlformats.org/drawingml/2006/main" noGrp="1"/>
+          </p:cNvSpPr>
+          <p:nvPr/>
+        </p:nvSpPr>
+        <p:spPr>
+          <a:xfrm xmlns:a="http://schemas.openxmlformats.org/drawingml/2006/main">
+            <a:off x="857250" y="4324350"/>
+            <a:ext cx="3048000" cy="352425"/>
+          </a:xfrm>
+          <a:prstGeom xmlns:a="http://schemas.openxmlformats.org/drawingml/2006/main" prst="rect">
+            <a:avLst/>
+          </a:prstGeom>
+          <a:noFill xmlns:a="http://schemas.openxmlformats.org/drawingml/2006/main"/>
+          <a:ln xmlns:a="http://schemas.openxmlformats.org/drawingml/2006/main" w="0">
+            <a:noFill/>
+            <a:prstDash val="solid"/>
+          </a:ln>
+        </p:spPr>
+        <p:txBody>
+          <a:bodyPr xmlns:a="http://schemas.openxmlformats.org/drawingml/2006/main"/>
+          <a:lstStyle xmlns:a="http://schemas.openxmlformats.org/drawingml/2006/main"/>
+          <a:p xmlns:a="http://schemas.openxmlformats.org/drawingml/2006/main">
+            <a:pPr>
+              <a:defRPr sz="750" b="1">
+                <a:solidFill>
+                  <a:srgbClr val="132F4C"/>
+                </a:solidFill>
+              </a:defRPr>
+            </a:pPr>
+            <a:r>
+              <a:rPr sz="750" b="1">
+                <a:solidFill>
+                  <a:srgbClr val="132F4C"/>
+                </a:solidFill>
+              </a:rPr>
+              <a:t>6 cases · 88 scenario-days</a:t>
+            </a:r>
+          </a:p>
+          <a:p xmlns:a="http://schemas.openxmlformats.org/drawingml/2006/main">
+            <a:pPr>
+              <a:defRPr sz="750" b="1">
+                <a:solidFill>
+                  <a:srgbClr val="132F4C"/>
+                </a:solidFill>
+              </a:defRPr>
+            </a:pPr>
+            <a:r>
+              <a:rPr sz="750" b="1">
+                <a:solidFill>
+                  <a:srgbClr val="132F4C"/>
+                </a:solidFill>
+              </a:rPr>
+              <a:t>12 multi-day paths · 176 daily executions</a:t>
+            </a:r>
+          </a:p>
+        </p:txBody>
+      </p:sp>
+      <p:sp>
+        <p:nvSpPr>
+          <p:cNvPr id="87" name="">
+            <a:extLst xmlns:a="http://schemas.openxmlformats.org/drawingml/2006/main">
+              <a:ext uri="{FF2B5EF4-FFF2-40B4-BE49-F238E27FC236}">
+                <a16:creationId xmlns:a16="http://schemas.microsoft.com/office/drawing/2014/main" id="{C97275DC-C493-48B8-972B-E7BE38A8A1CE}"/>
+              </a:ext>
+            </a:extLst>
+          </p:cNvPr>
+          <p:cNvSpPr>
+            <a:spLocks xmlns:a="http://schemas.openxmlformats.org/drawingml/2006/main" noGrp="1"/>
+          </p:cNvSpPr>
+          <p:nvPr/>
+        </p:nvSpPr>
+        <p:spPr>
+          <a:xfrm xmlns:a="http://schemas.openxmlformats.org/drawingml/2006/main">
+            <a:off x="857250" y="4733925"/>
+            <a:ext cx="3048000" cy="314325"/>
           </a:xfrm>
           <a:prstGeom xmlns:a="http://schemas.openxmlformats.org/drawingml/2006/main" prst="rect">
             <a:avLst/>
@@ -14700,56 +16645,755 @@
             <a:pPr>
               <a:defRPr sz="675">
                 <a:solidFill>
+                  <a:srgbClr val="486581"/>
+                </a:solidFill>
+              </a:defRPr>
+            </a:pPr>
+            <a:r>
+              <a:rPr sz="675">
+                <a:solidFill>
+                  <a:srgbClr val="486581"/>
+                </a:solidFill>
+              </a:rPr>
+              <a:t>补充证据 · 164 SOC boundaries</a:t>
+            </a:r>
+          </a:p>
+        </p:txBody>
+      </p:sp>
+      <p:sp>
+        <p:nvSpPr>
+          <p:cNvPr id="88" name="">
+            <a:extLst xmlns:a="http://schemas.openxmlformats.org/drawingml/2006/main">
+              <a:ext uri="{FF2B5EF4-FFF2-40B4-BE49-F238E27FC236}">
+                <a16:creationId xmlns:a16="http://schemas.microsoft.com/office/drawing/2014/main" id="{7C208B56-1B70-41D5-92C0-9E1624026C9D}"/>
+              </a:ext>
+            </a:extLst>
+          </p:cNvPr>
+          <p:cNvSpPr>
+            <a:spLocks xmlns:a="http://schemas.openxmlformats.org/drawingml/2006/main" noGrp="1"/>
+          </p:cNvSpPr>
+          <p:nvPr/>
+        </p:nvSpPr>
+        <p:spPr>
+          <a:xfrm xmlns:a="http://schemas.openxmlformats.org/drawingml/2006/main">
+            <a:off x="4381500" y="3448050"/>
+            <a:ext cx="3429000" cy="1676400"/>
+          </a:xfrm>
+          <a:prstGeom xmlns:a="http://schemas.openxmlformats.org/drawingml/2006/main" prst="rect">
+            <a:avLst/>
+          </a:prstGeom>
+          <a:solidFill xmlns:a="http://schemas.openxmlformats.org/drawingml/2006/main">
+            <a:srgbClr val="F5F0FF"/>
+          </a:solidFill>
+          <a:ln xmlns:a="http://schemas.openxmlformats.org/drawingml/2006/main" w="9525">
+            <a:solidFill>
+              <a:srgbClr val="C7DDF0"/>
+            </a:solidFill>
+            <a:prstDash val="solid"/>
+          </a:ln>
+        </p:spPr>
+      </p:sp>
+      <p:sp>
+        <p:nvSpPr>
+          <p:cNvPr id="89" name="">
+            <a:extLst xmlns:a="http://schemas.openxmlformats.org/drawingml/2006/main">
+              <a:ext uri="{FF2B5EF4-FFF2-40B4-BE49-F238E27FC236}">
+                <a16:creationId xmlns:a16="http://schemas.microsoft.com/office/drawing/2014/main" id="{654D0EC9-6AF6-4EEE-8A4F-111CDE6B5E73}"/>
+              </a:ext>
+            </a:extLst>
+          </p:cNvPr>
+          <p:cNvSpPr>
+            <a:spLocks xmlns:a="http://schemas.openxmlformats.org/drawingml/2006/main" noGrp="1"/>
+          </p:cNvSpPr>
+          <p:nvPr/>
+        </p:nvSpPr>
+        <p:spPr>
+          <a:xfrm xmlns:a="http://schemas.openxmlformats.org/drawingml/2006/main">
+            <a:off x="4381500" y="3448050"/>
+            <a:ext cx="66675" cy="1676400"/>
+          </a:xfrm>
+          <a:prstGeom xmlns:a="http://schemas.openxmlformats.org/drawingml/2006/main" prst="rect">
+            <a:avLst/>
+          </a:prstGeom>
+          <a:solidFill xmlns:a="http://schemas.openxmlformats.org/drawingml/2006/main">
+            <a:srgbClr val="7A5AF8"/>
+          </a:solidFill>
+          <a:ln xmlns:a="http://schemas.openxmlformats.org/drawingml/2006/main" w="9525">
+            <a:solidFill>
+              <a:srgbClr val="7A5AF8"/>
+            </a:solidFill>
+            <a:prstDash val="solid"/>
+          </a:ln>
+        </p:spPr>
+      </p:sp>
+      <p:sp>
+        <p:nvSpPr>
+          <p:cNvPr id="90" name="">
+            <a:extLst xmlns:a="http://schemas.openxmlformats.org/drawingml/2006/main">
+              <a:ext uri="{FF2B5EF4-FFF2-40B4-BE49-F238E27FC236}">
+                <a16:creationId xmlns:a16="http://schemas.microsoft.com/office/drawing/2014/main" id="{4CD645A7-1E10-457A-913F-49DA6803ABDB}"/>
+              </a:ext>
+            </a:extLst>
+          </p:cNvPr>
+          <p:cNvSpPr>
+            <a:spLocks xmlns:a="http://schemas.openxmlformats.org/drawingml/2006/main" noGrp="1"/>
+          </p:cNvSpPr>
+          <p:nvPr/>
+        </p:nvSpPr>
+        <p:spPr>
+          <a:xfrm xmlns:a="http://schemas.openxmlformats.org/drawingml/2006/main">
+            <a:off x="4572000" y="3600450"/>
+            <a:ext cx="323850" cy="285750"/>
+          </a:xfrm>
+          <a:prstGeom xmlns:a="http://schemas.openxmlformats.org/drawingml/2006/main" prst="rect">
+            <a:avLst/>
+          </a:prstGeom>
+          <a:noFill xmlns:a="http://schemas.openxmlformats.org/drawingml/2006/main"/>
+          <a:ln xmlns:a="http://schemas.openxmlformats.org/drawingml/2006/main" w="0">
+            <a:noFill/>
+            <a:prstDash val="solid"/>
+          </a:ln>
+        </p:spPr>
+        <p:txBody>
+          <a:bodyPr xmlns:a="http://schemas.openxmlformats.org/drawingml/2006/main"/>
+          <a:lstStyle xmlns:a="http://schemas.openxmlformats.org/drawingml/2006/main"/>
+          <a:p xmlns:a="http://schemas.openxmlformats.org/drawingml/2006/main">
+            <a:pPr>
+              <a:defRPr sz="1725" b="1">
+                <a:solidFill>
+                  <a:srgbClr val="7A5AF8"/>
+                </a:solidFill>
+              </a:defRPr>
+            </a:pPr>
+            <a:r>
+              <a:rPr sz="1725" b="1">
+                <a:solidFill>
+                  <a:srgbClr val="7A5AF8"/>
+                </a:solidFill>
+              </a:rPr>
+              <a:t>E</a:t>
+            </a:r>
+          </a:p>
+        </p:txBody>
+      </p:sp>
+      <p:sp>
+        <p:nvSpPr>
+          <p:cNvPr id="91" name="">
+            <a:extLst xmlns:a="http://schemas.openxmlformats.org/drawingml/2006/main">
+              <a:ext uri="{FF2B5EF4-FFF2-40B4-BE49-F238E27FC236}">
+                <a16:creationId xmlns:a16="http://schemas.microsoft.com/office/drawing/2014/main" id="{F06CA767-8D80-461E-B01D-B079AC1931B0}"/>
+              </a:ext>
+            </a:extLst>
+          </p:cNvPr>
+          <p:cNvSpPr>
+            <a:spLocks xmlns:a="http://schemas.openxmlformats.org/drawingml/2006/main" noGrp="1"/>
+          </p:cNvSpPr>
+          <p:nvPr/>
+        </p:nvSpPr>
+        <p:spPr>
+          <a:xfrm xmlns:a="http://schemas.openxmlformats.org/drawingml/2006/main">
+            <a:off x="4991100" y="3609975"/>
+            <a:ext cx="1257300" cy="247650"/>
+          </a:xfrm>
+          <a:prstGeom xmlns:a="http://schemas.openxmlformats.org/drawingml/2006/main" prst="rect">
+            <a:avLst/>
+          </a:prstGeom>
+          <a:noFill xmlns:a="http://schemas.openxmlformats.org/drawingml/2006/main"/>
+          <a:ln xmlns:a="http://schemas.openxmlformats.org/drawingml/2006/main" w="0">
+            <a:noFill/>
+            <a:prstDash val="solid"/>
+          </a:ln>
+        </p:spPr>
+        <p:txBody>
+          <a:bodyPr xmlns:a="http://schemas.openxmlformats.org/drawingml/2006/main"/>
+          <a:lstStyle xmlns:a="http://schemas.openxmlformats.org/drawingml/2006/main"/>
+          <a:p xmlns:a="http://schemas.openxmlformats.org/drawingml/2006/main">
+            <a:pPr>
+              <a:defRPr sz="1200" b="1">
+                <a:solidFill>
+                  <a:srgbClr val="0F3456"/>
+                </a:solidFill>
+              </a:defRPr>
+            </a:pPr>
+            <a:r>
+              <a:rPr sz="1200" b="1">
+                <a:solidFill>
+                  <a:srgbClr val="0F3456"/>
+                </a:solidFill>
+              </a:rPr>
+              <a:t>概率样本</a:t>
+            </a:r>
+          </a:p>
+        </p:txBody>
+      </p:sp>
+      <p:sp>
+        <p:nvSpPr>
+          <p:cNvPr id="92" name="">
+            <a:extLst xmlns:a="http://schemas.openxmlformats.org/drawingml/2006/main">
+              <a:ext uri="{FF2B5EF4-FFF2-40B4-BE49-F238E27FC236}">
+                <a16:creationId xmlns:a16="http://schemas.microsoft.com/office/drawing/2014/main" id="{DDD7A816-53B8-4CB4-9341-05802819C340}"/>
+              </a:ext>
+            </a:extLst>
+          </p:cNvPr>
+          <p:cNvSpPr>
+            <a:spLocks xmlns:a="http://schemas.openxmlformats.org/drawingml/2006/main" noGrp="1"/>
+          </p:cNvSpPr>
+          <p:nvPr/>
+        </p:nvSpPr>
+        <p:spPr>
+          <a:xfrm xmlns:a="http://schemas.openxmlformats.org/drawingml/2006/main">
+            <a:off x="4572000" y="3914775"/>
+            <a:ext cx="3048000" cy="171450"/>
+          </a:xfrm>
+          <a:prstGeom xmlns:a="http://schemas.openxmlformats.org/drawingml/2006/main" prst="rect">
+            <a:avLst/>
+          </a:prstGeom>
+          <a:noFill xmlns:a="http://schemas.openxmlformats.org/drawingml/2006/main"/>
+          <a:ln xmlns:a="http://schemas.openxmlformats.org/drawingml/2006/main" w="0">
+            <a:noFill/>
+            <a:prstDash val="solid"/>
+          </a:ln>
+        </p:spPr>
+        <p:txBody>
+          <a:bodyPr xmlns:a="http://schemas.openxmlformats.org/drawingml/2006/main"/>
+          <a:lstStyle xmlns:a="http://schemas.openxmlformats.org/drawingml/2006/main"/>
+          <a:p xmlns:a="http://schemas.openxmlformats.org/drawingml/2006/main">
+            <a:pPr>
+              <a:defRPr sz="750">
+                <a:solidFill>
                   <a:srgbClr val="5B7190"/>
                 </a:solidFill>
               </a:defRPr>
             </a:pPr>
             <a:r>
-              <a:rPr sz="675">
+              <a:rPr sz="750">
                 <a:solidFill>
                   <a:srgbClr val="5B7190"/>
                 </a:solidFill>
               </a:rPr>
-              <a:t>39 scenarios</a:t>
-            </a:r>
-          </a:p>
+              <a:t>fixed-seed 独立样本</a:t>
+            </a:r>
+          </a:p>
+        </p:txBody>
+      </p:sp>
+      <p:sp>
+        <p:nvSpPr>
+          <p:cNvPr id="93" name="">
+            <a:extLst xmlns:a="http://schemas.openxmlformats.org/drawingml/2006/main">
+              <a:ext uri="{FF2B5EF4-FFF2-40B4-BE49-F238E27FC236}">
+                <a16:creationId xmlns:a16="http://schemas.microsoft.com/office/drawing/2014/main" id="{87FB2459-727D-44C0-B638-2B1D543174F6}"/>
+              </a:ext>
+            </a:extLst>
+          </p:cNvPr>
+          <p:cNvSpPr>
+            <a:spLocks xmlns:a="http://schemas.openxmlformats.org/drawingml/2006/main" noGrp="1"/>
+          </p:cNvSpPr>
+          <p:nvPr/>
+        </p:nvSpPr>
+        <p:spPr>
+          <a:xfrm xmlns:a="http://schemas.openxmlformats.org/drawingml/2006/main">
+            <a:off x="4572000" y="4171950"/>
+            <a:ext cx="762000" cy="152400"/>
+          </a:xfrm>
+          <a:prstGeom xmlns:a="http://schemas.openxmlformats.org/drawingml/2006/main" prst="rect">
+            <a:avLst/>
+          </a:prstGeom>
+          <a:noFill xmlns:a="http://schemas.openxmlformats.org/drawingml/2006/main"/>
+          <a:ln xmlns:a="http://schemas.openxmlformats.org/drawingml/2006/main" w="0">
+            <a:noFill/>
+            <a:prstDash val="solid"/>
+          </a:ln>
+        </p:spPr>
+        <p:txBody>
+          <a:bodyPr xmlns:a="http://schemas.openxmlformats.org/drawingml/2006/main"/>
+          <a:lstStyle xmlns:a="http://schemas.openxmlformats.org/drawingml/2006/main"/>
+          <a:p xmlns:a="http://schemas.openxmlformats.org/drawingml/2006/main">
+            <a:pPr>
+              <a:defRPr sz="675" b="1">
+                <a:solidFill>
+                  <a:srgbClr val="7A5AF8"/>
+                </a:solidFill>
+              </a:defRPr>
+            </a:pPr>
+            <a:r>
+              <a:rPr sz="675" b="1">
+                <a:solidFill>
+                  <a:srgbClr val="7A5AF8"/>
+                </a:solidFill>
+              </a:rPr>
+              <a:t>主规模</a:t>
+            </a:r>
+          </a:p>
+        </p:txBody>
+      </p:sp>
+      <p:sp>
+        <p:nvSpPr>
+          <p:cNvPr id="94" name="">
+            <a:extLst xmlns:a="http://schemas.openxmlformats.org/drawingml/2006/main">
+              <a:ext uri="{FF2B5EF4-FFF2-40B4-BE49-F238E27FC236}">
+                <a16:creationId xmlns:a16="http://schemas.microsoft.com/office/drawing/2014/main" id="{52A41179-845B-4DE1-BF67-6A3DF41CFB01}"/>
+              </a:ext>
+            </a:extLst>
+          </p:cNvPr>
+          <p:cNvSpPr>
+            <a:spLocks xmlns:a="http://schemas.openxmlformats.org/drawingml/2006/main" noGrp="1"/>
+          </p:cNvSpPr>
+          <p:nvPr/>
+        </p:nvSpPr>
+        <p:spPr>
+          <a:xfrm xmlns:a="http://schemas.openxmlformats.org/drawingml/2006/main">
+            <a:off x="4572000" y="4324350"/>
+            <a:ext cx="3048000" cy="352425"/>
+          </a:xfrm>
+          <a:prstGeom xmlns:a="http://schemas.openxmlformats.org/drawingml/2006/main" prst="rect">
+            <a:avLst/>
+          </a:prstGeom>
+          <a:noFill xmlns:a="http://schemas.openxmlformats.org/drawingml/2006/main"/>
+          <a:ln xmlns:a="http://schemas.openxmlformats.org/drawingml/2006/main" w="0">
+            <a:noFill/>
+            <a:prstDash val="solid"/>
+          </a:ln>
+        </p:spPr>
+        <p:txBody>
+          <a:bodyPr xmlns:a="http://schemas.openxmlformats.org/drawingml/2006/main"/>
+          <a:lstStyle xmlns:a="http://schemas.openxmlformats.org/drawingml/2006/main"/>
+          <a:p xmlns:a="http://schemas.openxmlformats.org/drawingml/2006/main">
+            <a:pPr>
+              <a:defRPr sz="750" b="1">
+                <a:solidFill>
+                  <a:srgbClr val="132F4C"/>
+                </a:solidFill>
+              </a:defRPr>
+            </a:pPr>
+            <a:r>
+              <a:rPr sz="750" b="1">
+                <a:solidFill>
+                  <a:srgbClr val="132F4C"/>
+                </a:solidFill>
+              </a:rPr>
+              <a:t>192 samples · 384 sampled paths</a:t>
+            </a:r>
+          </a:p>
+          <a:p xmlns:a="http://schemas.openxmlformats.org/drawingml/2006/main">
+            <a:pPr>
+              <a:defRPr sz="750" b="1">
+                <a:solidFill>
+                  <a:srgbClr val="132F4C"/>
+                </a:solidFill>
+              </a:defRPr>
+            </a:pPr>
+            <a:r>
+              <a:rPr sz="750" b="1">
+                <a:solidFill>
+                  <a:srgbClr val="132F4C"/>
+                </a:solidFill>
+              </a:rPr>
+              <a:t>6 anchors · 390 executions</a:t>
+            </a:r>
+          </a:p>
+        </p:txBody>
+      </p:sp>
+      <p:sp>
+        <p:nvSpPr>
+          <p:cNvPr id="95" name="">
+            <a:extLst xmlns:a="http://schemas.openxmlformats.org/drawingml/2006/main">
+              <a:ext uri="{FF2B5EF4-FFF2-40B4-BE49-F238E27FC236}">
+                <a16:creationId xmlns:a16="http://schemas.microsoft.com/office/drawing/2014/main" id="{811AB677-8BDA-45F1-B552-7A96823A9330}"/>
+              </a:ext>
+            </a:extLst>
+          </p:cNvPr>
+          <p:cNvSpPr>
+            <a:spLocks xmlns:a="http://schemas.openxmlformats.org/drawingml/2006/main" noGrp="1"/>
+          </p:cNvSpPr>
+          <p:nvPr/>
+        </p:nvSpPr>
+        <p:spPr>
+          <a:xfrm xmlns:a="http://schemas.openxmlformats.org/drawingml/2006/main">
+            <a:off x="4572000" y="4733925"/>
+            <a:ext cx="3048000" cy="314325"/>
+          </a:xfrm>
+          <a:prstGeom xmlns:a="http://schemas.openxmlformats.org/drawingml/2006/main" prst="rect">
+            <a:avLst/>
+          </a:prstGeom>
+          <a:noFill xmlns:a="http://schemas.openxmlformats.org/drawingml/2006/main"/>
+          <a:ln xmlns:a="http://schemas.openxmlformats.org/drawingml/2006/main" w="0">
+            <a:noFill/>
+            <a:prstDash val="solid"/>
+          </a:ln>
+        </p:spPr>
+        <p:txBody>
+          <a:bodyPr xmlns:a="http://schemas.openxmlformats.org/drawingml/2006/main"/>
+          <a:lstStyle xmlns:a="http://schemas.openxmlformats.org/drawingml/2006/main"/>
           <a:p xmlns:a="http://schemas.openxmlformats.org/drawingml/2006/main">
             <a:pPr>
               <a:defRPr sz="675">
                 <a:solidFill>
+                  <a:srgbClr val="486581"/>
+                </a:solidFill>
+              </a:defRPr>
+            </a:pPr>
+            <a:r>
+              <a:rPr sz="675">
+                <a:solidFill>
+                  <a:srgbClr val="486581"/>
+                </a:solidFill>
+              </a:rPr>
+              <a:t>补充证据 · 192 comparisons · 384 regrets</a:t>
+            </a:r>
+          </a:p>
+        </p:txBody>
+      </p:sp>
+      <p:sp>
+        <p:nvSpPr>
+          <p:cNvPr id="96" name="">
+            <a:extLst xmlns:a="http://schemas.openxmlformats.org/drawingml/2006/main">
+              <a:ext uri="{FF2B5EF4-FFF2-40B4-BE49-F238E27FC236}">
+                <a16:creationId xmlns:a16="http://schemas.microsoft.com/office/drawing/2014/main" id="{1BEA9FB4-B7BC-49AE-85B0-600CFF9701BC}"/>
+              </a:ext>
+            </a:extLst>
+          </p:cNvPr>
+          <p:cNvSpPr>
+            <a:spLocks xmlns:a="http://schemas.openxmlformats.org/drawingml/2006/main" noGrp="1"/>
+          </p:cNvSpPr>
+          <p:nvPr/>
+        </p:nvSpPr>
+        <p:spPr>
+          <a:xfrm xmlns:a="http://schemas.openxmlformats.org/drawingml/2006/main">
+            <a:off x="8096250" y="3448050"/>
+            <a:ext cx="3429000" cy="1676400"/>
+          </a:xfrm>
+          <a:prstGeom xmlns:a="http://schemas.openxmlformats.org/drawingml/2006/main" prst="rect">
+            <a:avLst/>
+          </a:prstGeom>
+          <a:solidFill xmlns:a="http://schemas.openxmlformats.org/drawingml/2006/main">
+            <a:srgbClr val="F5F0FF"/>
+          </a:solidFill>
+          <a:ln xmlns:a="http://schemas.openxmlformats.org/drawingml/2006/main" w="9525">
+            <a:solidFill>
+              <a:srgbClr val="C7DDF0"/>
+            </a:solidFill>
+            <a:prstDash val="solid"/>
+          </a:ln>
+        </p:spPr>
+      </p:sp>
+      <p:sp>
+        <p:nvSpPr>
+          <p:cNvPr id="97" name="">
+            <a:extLst xmlns:a="http://schemas.openxmlformats.org/drawingml/2006/main">
+              <a:ext uri="{FF2B5EF4-FFF2-40B4-BE49-F238E27FC236}">
+                <a16:creationId xmlns:a16="http://schemas.microsoft.com/office/drawing/2014/main" id="{A6F07FC4-28AC-411D-BFAA-4AB2CD1A0305}"/>
+              </a:ext>
+            </a:extLst>
+          </p:cNvPr>
+          <p:cNvSpPr>
+            <a:spLocks xmlns:a="http://schemas.openxmlformats.org/drawingml/2006/main" noGrp="1"/>
+          </p:cNvSpPr>
+          <p:nvPr/>
+        </p:nvSpPr>
+        <p:spPr>
+          <a:xfrm xmlns:a="http://schemas.openxmlformats.org/drawingml/2006/main">
+            <a:off x="8096250" y="3448050"/>
+            <a:ext cx="66675" cy="1676400"/>
+          </a:xfrm>
+          <a:prstGeom xmlns:a="http://schemas.openxmlformats.org/drawingml/2006/main" prst="rect">
+            <a:avLst/>
+          </a:prstGeom>
+          <a:solidFill xmlns:a="http://schemas.openxmlformats.org/drawingml/2006/main">
+            <a:srgbClr val="7A5AF8"/>
+          </a:solidFill>
+          <a:ln xmlns:a="http://schemas.openxmlformats.org/drawingml/2006/main" w="9525">
+            <a:solidFill>
+              <a:srgbClr val="7A5AF8"/>
+            </a:solidFill>
+            <a:prstDash val="solid"/>
+          </a:ln>
+        </p:spPr>
+      </p:sp>
+      <p:sp>
+        <p:nvSpPr>
+          <p:cNvPr id="98" name="">
+            <a:extLst xmlns:a="http://schemas.openxmlformats.org/drawingml/2006/main">
+              <a:ext uri="{FF2B5EF4-FFF2-40B4-BE49-F238E27FC236}">
+                <a16:creationId xmlns:a16="http://schemas.microsoft.com/office/drawing/2014/main" id="{20891352-A97B-40B9-99FC-B5D618D881EE}"/>
+              </a:ext>
+            </a:extLst>
+          </p:cNvPr>
+          <p:cNvSpPr>
+            <a:spLocks xmlns:a="http://schemas.openxmlformats.org/drawingml/2006/main" noGrp="1"/>
+          </p:cNvSpPr>
+          <p:nvPr/>
+        </p:nvSpPr>
+        <p:spPr>
+          <a:xfrm xmlns:a="http://schemas.openxmlformats.org/drawingml/2006/main">
+            <a:off x="8286750" y="3600450"/>
+            <a:ext cx="323850" cy="285750"/>
+          </a:xfrm>
+          <a:prstGeom xmlns:a="http://schemas.openxmlformats.org/drawingml/2006/main" prst="rect">
+            <a:avLst/>
+          </a:prstGeom>
+          <a:noFill xmlns:a="http://schemas.openxmlformats.org/drawingml/2006/main"/>
+          <a:ln xmlns:a="http://schemas.openxmlformats.org/drawingml/2006/main" w="0">
+            <a:noFill/>
+            <a:prstDash val="solid"/>
+          </a:ln>
+        </p:spPr>
+        <p:txBody>
+          <a:bodyPr xmlns:a="http://schemas.openxmlformats.org/drawingml/2006/main"/>
+          <a:lstStyle xmlns:a="http://schemas.openxmlformats.org/drawingml/2006/main"/>
+          <a:p xmlns:a="http://schemas.openxmlformats.org/drawingml/2006/main">
+            <a:pPr>
+              <a:defRPr sz="1725" b="1">
+                <a:solidFill>
+                  <a:srgbClr val="7A5AF8"/>
+                </a:solidFill>
+              </a:defRPr>
+            </a:pPr>
+            <a:r>
+              <a:rPr sz="1725" b="1">
+                <a:solidFill>
+                  <a:srgbClr val="7A5AF8"/>
+                </a:solidFill>
+              </a:rPr>
+              <a:t>F</a:t>
+            </a:r>
+          </a:p>
+        </p:txBody>
+      </p:sp>
+      <p:sp>
+        <p:nvSpPr>
+          <p:cNvPr id="99" name="">
+            <a:extLst xmlns:a="http://schemas.openxmlformats.org/drawingml/2006/main">
+              <a:ext uri="{FF2B5EF4-FFF2-40B4-BE49-F238E27FC236}">
+                <a16:creationId xmlns:a16="http://schemas.microsoft.com/office/drawing/2014/main" id="{340BC874-068E-4809-A502-CDD68D34704A}"/>
+              </a:ext>
+            </a:extLst>
+          </p:cNvPr>
+          <p:cNvSpPr>
+            <a:spLocks xmlns:a="http://schemas.openxmlformats.org/drawingml/2006/main" noGrp="1"/>
+          </p:cNvSpPr>
+          <p:nvPr/>
+        </p:nvSpPr>
+        <p:spPr>
+          <a:xfrm xmlns:a="http://schemas.openxmlformats.org/drawingml/2006/main">
+            <a:off x="8705850" y="3609975"/>
+            <a:ext cx="1257300" cy="247650"/>
+          </a:xfrm>
+          <a:prstGeom xmlns:a="http://schemas.openxmlformats.org/drawingml/2006/main" prst="rect">
+            <a:avLst/>
+          </a:prstGeom>
+          <a:noFill xmlns:a="http://schemas.openxmlformats.org/drawingml/2006/main"/>
+          <a:ln xmlns:a="http://schemas.openxmlformats.org/drawingml/2006/main" w="0">
+            <a:noFill/>
+            <a:prstDash val="solid"/>
+          </a:ln>
+        </p:spPr>
+        <p:txBody>
+          <a:bodyPr xmlns:a="http://schemas.openxmlformats.org/drawingml/2006/main"/>
+          <a:lstStyle xmlns:a="http://schemas.openxmlformats.org/drawingml/2006/main"/>
+          <a:p xmlns:a="http://schemas.openxmlformats.org/drawingml/2006/main">
+            <a:pPr>
+              <a:defRPr sz="1200" b="1">
+                <a:solidFill>
+                  <a:srgbClr val="0F3456"/>
+                </a:solidFill>
+              </a:defRPr>
+            </a:pPr>
+            <a:r>
+              <a:rPr sz="1200" b="1">
+                <a:solidFill>
+                  <a:srgbClr val="0F3456"/>
+                </a:solidFill>
+              </a:rPr>
+              <a:t>相关尾部</a:t>
+            </a:r>
+          </a:p>
+        </p:txBody>
+      </p:sp>
+      <p:sp>
+        <p:nvSpPr>
+          <p:cNvPr id="100" name="">
+            <a:extLst xmlns:a="http://schemas.openxmlformats.org/drawingml/2006/main">
+              <a:ext uri="{FF2B5EF4-FFF2-40B4-BE49-F238E27FC236}">
+                <a16:creationId xmlns:a16="http://schemas.microsoft.com/office/drawing/2014/main" id="{48B30C27-0C2C-4530-A4DD-B7A07AE2DB5C}"/>
+              </a:ext>
+            </a:extLst>
+          </p:cNvPr>
+          <p:cNvSpPr>
+            <a:spLocks xmlns:a="http://schemas.openxmlformats.org/drawingml/2006/main" noGrp="1"/>
+          </p:cNvSpPr>
+          <p:nvPr/>
+        </p:nvSpPr>
+        <p:spPr>
+          <a:xfrm xmlns:a="http://schemas.openxmlformats.org/drawingml/2006/main">
+            <a:off x="8286750" y="3914775"/>
+            <a:ext cx="3048000" cy="171450"/>
+          </a:xfrm>
+          <a:prstGeom xmlns:a="http://schemas.openxmlformats.org/drawingml/2006/main" prst="rect">
+            <a:avLst/>
+          </a:prstGeom>
+          <a:noFill xmlns:a="http://schemas.openxmlformats.org/drawingml/2006/main"/>
+          <a:ln xmlns:a="http://schemas.openxmlformats.org/drawingml/2006/main" w="0">
+            <a:noFill/>
+            <a:prstDash val="solid"/>
+          </a:ln>
+        </p:spPr>
+        <p:txBody>
+          <a:bodyPr xmlns:a="http://schemas.openxmlformats.org/drawingml/2006/main"/>
+          <a:lstStyle xmlns:a="http://schemas.openxmlformats.org/drawingml/2006/main"/>
+          <a:p xmlns:a="http://schemas.openxmlformats.org/drawingml/2006/main">
+            <a:pPr>
+              <a:defRPr sz="750">
+                <a:solidFill>
                   <a:srgbClr val="5B7190"/>
                 </a:solidFill>
               </a:defRPr>
             </a:pPr>
             <a:r>
-              <a:rPr sz="675">
+              <a:rPr sz="750">
                 <a:solidFill>
                   <a:srgbClr val="5B7190"/>
                 </a:solidFill>
               </a:rPr>
-              <a:t>78 independent actual</a:t>
-            </a:r>
-          </a:p>
-        </p:txBody>
-      </p:sp>
-      <p:sp>
-        <p:nvSpPr>
-          <p:cNvPr id="47" name="">
-            <a:extLst xmlns:a="http://schemas.openxmlformats.org/drawingml/2006/main">
-              <a:ext uri="{FF2B5EF4-FFF2-40B4-BE49-F238E27FC236}">
-                <a16:creationId xmlns:a16="http://schemas.microsoft.com/office/drawing/2014/main" id="{77914789-B6A8-4A3C-8F0A-5AC70570BC42}"/>
-              </a:ext>
-            </a:extLst>
-          </p:cNvPr>
-          <p:cNvSpPr>
-            <a:spLocks xmlns:a="http://schemas.openxmlformats.org/drawingml/2006/main" noGrp="1"/>
-          </p:cNvSpPr>
-          <p:nvPr/>
-        </p:nvSpPr>
-        <p:spPr>
-          <a:xfrm xmlns:a="http://schemas.openxmlformats.org/drawingml/2006/main">
-            <a:off x="6029325" y="3448050"/>
-            <a:ext cx="1476375" cy="438150"/>
+              <a:t>跨日相关 + deterministic tail</a:t>
+            </a:r>
+          </a:p>
+        </p:txBody>
+      </p:sp>
+      <p:sp>
+        <p:nvSpPr>
+          <p:cNvPr id="101" name="">
+            <a:extLst xmlns:a="http://schemas.openxmlformats.org/drawingml/2006/main">
+              <a:ext uri="{FF2B5EF4-FFF2-40B4-BE49-F238E27FC236}">
+                <a16:creationId xmlns:a16="http://schemas.microsoft.com/office/drawing/2014/main" id="{AF807274-6469-418C-B338-5A3585F7F47C}"/>
+              </a:ext>
+            </a:extLst>
+          </p:cNvPr>
+          <p:cNvSpPr>
+            <a:spLocks xmlns:a="http://schemas.openxmlformats.org/drawingml/2006/main" noGrp="1"/>
+          </p:cNvSpPr>
+          <p:nvPr/>
+        </p:nvSpPr>
+        <p:spPr>
+          <a:xfrm xmlns:a="http://schemas.openxmlformats.org/drawingml/2006/main">
+            <a:off x="8286750" y="4171950"/>
+            <a:ext cx="762000" cy="152400"/>
+          </a:xfrm>
+          <a:prstGeom xmlns:a="http://schemas.openxmlformats.org/drawingml/2006/main" prst="rect">
+            <a:avLst/>
+          </a:prstGeom>
+          <a:noFill xmlns:a="http://schemas.openxmlformats.org/drawingml/2006/main"/>
+          <a:ln xmlns:a="http://schemas.openxmlformats.org/drawingml/2006/main" w="0">
+            <a:noFill/>
+            <a:prstDash val="solid"/>
+          </a:ln>
+        </p:spPr>
+        <p:txBody>
+          <a:bodyPr xmlns:a="http://schemas.openxmlformats.org/drawingml/2006/main"/>
+          <a:lstStyle xmlns:a="http://schemas.openxmlformats.org/drawingml/2006/main"/>
+          <a:p xmlns:a="http://schemas.openxmlformats.org/drawingml/2006/main">
+            <a:pPr>
+              <a:defRPr sz="675" b="1">
+                <a:solidFill>
+                  <a:srgbClr val="7A5AF8"/>
+                </a:solidFill>
+              </a:defRPr>
+            </a:pPr>
+            <a:r>
+              <a:rPr sz="675" b="1">
+                <a:solidFill>
+                  <a:srgbClr val="7A5AF8"/>
+                </a:solidFill>
+              </a:rPr>
+              <a:t>主规模</a:t>
+            </a:r>
+          </a:p>
+        </p:txBody>
+      </p:sp>
+      <p:sp>
+        <p:nvSpPr>
+          <p:cNvPr id="102" name="">
+            <a:extLst xmlns:a="http://schemas.openxmlformats.org/drawingml/2006/main">
+              <a:ext uri="{FF2B5EF4-FFF2-40B4-BE49-F238E27FC236}">
+                <a16:creationId xmlns:a16="http://schemas.microsoft.com/office/drawing/2014/main" id="{84425190-1E77-4588-8A3D-38C9B36EFD04}"/>
+              </a:ext>
+            </a:extLst>
+          </p:cNvPr>
+          <p:cNvSpPr>
+            <a:spLocks xmlns:a="http://schemas.openxmlformats.org/drawingml/2006/main" noGrp="1"/>
+          </p:cNvSpPr>
+          <p:nvPr/>
+        </p:nvSpPr>
+        <p:spPr>
+          <a:xfrm xmlns:a="http://schemas.openxmlformats.org/drawingml/2006/main">
+            <a:off x="8286750" y="4324350"/>
+            <a:ext cx="3048000" cy="352425"/>
+          </a:xfrm>
+          <a:prstGeom xmlns:a="http://schemas.openxmlformats.org/drawingml/2006/main" prst="rect">
+            <a:avLst/>
+          </a:prstGeom>
+          <a:noFill xmlns:a="http://schemas.openxmlformats.org/drawingml/2006/main"/>
+          <a:ln xmlns:a="http://schemas.openxmlformats.org/drawingml/2006/main" w="0">
+            <a:noFill/>
+            <a:prstDash val="solid"/>
+          </a:ln>
+        </p:spPr>
+        <p:txBody>
+          <a:bodyPr xmlns:a="http://schemas.openxmlformats.org/drawingml/2006/main"/>
+          <a:lstStyle xmlns:a="http://schemas.openxmlformats.org/drawingml/2006/main"/>
+          <a:p xmlns:a="http://schemas.openxmlformats.org/drawingml/2006/main">
+            <a:pPr>
+              <a:defRPr sz="750" b="1">
+                <a:solidFill>
+                  <a:srgbClr val="132F4C"/>
+                </a:solidFill>
+              </a:defRPr>
+            </a:pPr>
+            <a:r>
+              <a:rPr sz="750" b="1">
+                <a:solidFill>
+                  <a:srgbClr val="132F4C"/>
+                </a:solidFill>
+              </a:rPr>
+              <a:t>60 scenarios · 420 scenario-days</a:t>
+            </a:r>
+          </a:p>
+          <a:p xmlns:a="http://schemas.openxmlformats.org/drawingml/2006/main">
+            <a:pPr>
+              <a:defRPr sz="750" b="1">
+                <a:solidFill>
+                  <a:srgbClr val="132F4C"/>
+                </a:solidFill>
+              </a:defRPr>
+            </a:pPr>
+            <a:r>
+              <a:rPr sz="750" b="1">
+                <a:solidFill>
+                  <a:srgbClr val="132F4C"/>
+                </a:solidFill>
+              </a:rPr>
+              <a:t>126 seven-day paths · 882 daily executions</a:t>
+            </a:r>
+          </a:p>
+        </p:txBody>
+      </p:sp>
+      <p:sp>
+        <p:nvSpPr>
+          <p:cNvPr id="103" name="">
+            <a:extLst xmlns:a="http://schemas.openxmlformats.org/drawingml/2006/main">
+              <a:ext uri="{FF2B5EF4-FFF2-40B4-BE49-F238E27FC236}">
+                <a16:creationId xmlns:a16="http://schemas.microsoft.com/office/drawing/2014/main" id="{239916FB-4732-4010-AFEA-55FDA049F99B}"/>
+              </a:ext>
+            </a:extLst>
+          </p:cNvPr>
+          <p:cNvSpPr>
+            <a:spLocks xmlns:a="http://schemas.openxmlformats.org/drawingml/2006/main" noGrp="1"/>
+          </p:cNvSpPr>
+          <p:nvPr/>
+        </p:nvSpPr>
+        <p:spPr>
+          <a:xfrm xmlns:a="http://schemas.openxmlformats.org/drawingml/2006/main">
+            <a:off x="8286750" y="4733925"/>
+            <a:ext cx="3048000" cy="314325"/>
           </a:xfrm>
           <a:prstGeom xmlns:a="http://schemas.openxmlformats.org/drawingml/2006/main" prst="rect">
             <a:avLst/>
@@ -14767,56 +17411,122 @@
             <a:pPr>
               <a:defRPr sz="675">
                 <a:solidFill>
-                  <a:srgbClr val="5B7190"/>
+                  <a:srgbClr val="486581"/>
                 </a:solidFill>
               </a:defRPr>
             </a:pPr>
             <a:r>
               <a:rPr sz="675">
                 <a:solidFill>
-                  <a:srgbClr val="5B7190"/>
-                </a:solidFill>
-              </a:rPr>
-              <a:t>6 cases · 88 scenario-days</a:t>
+                  <a:srgbClr val="486581"/>
+                </a:solidFill>
+              </a:rPr>
+              <a:t>补充证据 · 21,168 hourly records</a:t>
             </a:r>
           </a:p>
           <a:p xmlns:a="http://schemas.openxmlformats.org/drawingml/2006/main">
             <a:pPr>
               <a:defRPr sz="675">
                 <a:solidFill>
-                  <a:srgbClr val="5B7190"/>
+                  <a:srgbClr val="486581"/>
                 </a:solidFill>
               </a:defRPr>
             </a:pPr>
             <a:r>
               <a:rPr sz="675">
                 <a:solidFill>
-                  <a:srgbClr val="5B7190"/>
-                </a:solidFill>
-              </a:rPr>
-              <a:t>12 paths · 176 daily</a:t>
-            </a:r>
-          </a:p>
-        </p:txBody>
-      </p:sp>
-      <p:sp>
-        <p:nvSpPr>
-          <p:cNvPr id="48" name="">
-            <a:extLst xmlns:a="http://schemas.openxmlformats.org/drawingml/2006/main">
-              <a:ext uri="{FF2B5EF4-FFF2-40B4-BE49-F238E27FC236}">
-                <a16:creationId xmlns:a16="http://schemas.microsoft.com/office/drawing/2014/main" id="{9CF8AC9F-85E8-4517-86B4-4781462CD3F2}"/>
-              </a:ext>
-            </a:extLst>
-          </p:cNvPr>
-          <p:cNvSpPr>
-            <a:spLocks xmlns:a="http://schemas.openxmlformats.org/drawingml/2006/main" noGrp="1"/>
-          </p:cNvSpPr>
-          <p:nvPr/>
-        </p:nvSpPr>
-        <p:spPr>
-          <a:xfrm xmlns:a="http://schemas.openxmlformats.org/drawingml/2006/main">
-            <a:off x="7800975" y="3448050"/>
-            <a:ext cx="1476375" cy="438150"/>
+                  <a:srgbClr val="486581"/>
+                </a:solidFill>
+              </a:rPr>
+              <a:t>756 SOC boundaries · 908 artifacts</a:t>
+            </a:r>
+          </a:p>
+        </p:txBody>
+      </p:sp>
+      <p:sp>
+        <p:nvSpPr>
+          <p:cNvPr id="104" name="">
+            <a:extLst xmlns:a="http://schemas.openxmlformats.org/drawingml/2006/main">
+              <a:ext uri="{FF2B5EF4-FFF2-40B4-BE49-F238E27FC236}">
+                <a16:creationId xmlns:a16="http://schemas.microsoft.com/office/drawing/2014/main" id="{FE5963BE-BEBD-4445-BBAF-DAF1F5A1769E}"/>
+              </a:ext>
+            </a:extLst>
+          </p:cNvPr>
+          <p:cNvSpPr>
+            <a:spLocks xmlns:a="http://schemas.openxmlformats.org/drawingml/2006/main" noGrp="1"/>
+          </p:cNvSpPr>
+          <p:nvPr/>
+        </p:nvSpPr>
+        <p:spPr>
+          <a:xfrm xmlns:a="http://schemas.openxmlformats.org/drawingml/2006/main">
+            <a:off x="666750" y="5286375"/>
+            <a:ext cx="5286375" cy="904875"/>
+          </a:xfrm>
+          <a:prstGeom xmlns:a="http://schemas.openxmlformats.org/drawingml/2006/main" prst="rect">
+            <a:avLst/>
+          </a:prstGeom>
+          <a:solidFill xmlns:a="http://schemas.openxmlformats.org/drawingml/2006/main">
+            <a:srgbClr val="FFFFFF"/>
+          </a:solidFill>
+          <a:ln xmlns:a="http://schemas.openxmlformats.org/drawingml/2006/main" w="9525">
+            <a:solidFill>
+              <a:srgbClr val="D7E3EE"/>
+            </a:solidFill>
+            <a:prstDash val="solid"/>
+          </a:ln>
+        </p:spPr>
+      </p:sp>
+      <p:sp>
+        <p:nvSpPr>
+          <p:cNvPr id="105" name="">
+            <a:extLst xmlns:a="http://schemas.openxmlformats.org/drawingml/2006/main">
+              <a:ext uri="{FF2B5EF4-FFF2-40B4-BE49-F238E27FC236}">
+                <a16:creationId xmlns:a16="http://schemas.microsoft.com/office/drawing/2014/main" id="{166D73CB-1DB3-4623-BC9D-E2C3523A849E}"/>
+              </a:ext>
+            </a:extLst>
+          </p:cNvPr>
+          <p:cNvSpPr>
+            <a:spLocks xmlns:a="http://schemas.openxmlformats.org/drawingml/2006/main" noGrp="1"/>
+          </p:cNvSpPr>
+          <p:nvPr/>
+        </p:nvSpPr>
+        <p:spPr>
+          <a:xfrm xmlns:a="http://schemas.openxmlformats.org/drawingml/2006/main">
+            <a:off x="666750" y="5286375"/>
+            <a:ext cx="66675" cy="904875"/>
+          </a:xfrm>
+          <a:prstGeom xmlns:a="http://schemas.openxmlformats.org/drawingml/2006/main" prst="rect">
+            <a:avLst/>
+          </a:prstGeom>
+          <a:solidFill xmlns:a="http://schemas.openxmlformats.org/drawingml/2006/main">
+            <a:srgbClr val="079455"/>
+          </a:solidFill>
+          <a:ln xmlns:a="http://schemas.openxmlformats.org/drawingml/2006/main" w="9525">
+            <a:solidFill>
+              <a:srgbClr val="079455"/>
+            </a:solidFill>
+            <a:prstDash val="solid"/>
+          </a:ln>
+        </p:spPr>
+      </p:sp>
+      <p:sp>
+        <p:nvSpPr>
+          <p:cNvPr id="106" name="">
+            <a:extLst xmlns:a="http://schemas.openxmlformats.org/drawingml/2006/main">
+              <a:ext uri="{FF2B5EF4-FFF2-40B4-BE49-F238E27FC236}">
+                <a16:creationId xmlns:a16="http://schemas.microsoft.com/office/drawing/2014/main" id="{C2BA9BFB-2DF8-4679-B909-908D3FE6B981}"/>
+              </a:ext>
+            </a:extLst>
+          </p:cNvPr>
+          <p:cNvSpPr>
+            <a:spLocks xmlns:a="http://schemas.openxmlformats.org/drawingml/2006/main" noGrp="1"/>
+          </p:cNvSpPr>
+          <p:nvPr/>
+        </p:nvSpPr>
+        <p:spPr>
+          <a:xfrm xmlns:a="http://schemas.openxmlformats.org/drawingml/2006/main">
+            <a:off x="876300" y="5438775"/>
+            <a:ext cx="4762500" cy="228600"/>
           </a:xfrm>
           <a:prstGeom xmlns:a="http://schemas.openxmlformats.org/drawingml/2006/main" prst="rect">
             <a:avLst/>
@@ -14832,58 +17542,157 @@
           <a:lstStyle xmlns:a="http://schemas.openxmlformats.org/drawingml/2006/main"/>
           <a:p xmlns:a="http://schemas.openxmlformats.org/drawingml/2006/main">
             <a:pPr>
-              <a:defRPr sz="675">
-                <a:solidFill>
-                  <a:srgbClr val="5B7190"/>
-                </a:solidFill>
-              </a:defRPr>
-            </a:pPr>
-            <a:r>
-              <a:rPr sz="675">
-                <a:solidFill>
-                  <a:srgbClr val="5B7190"/>
-                </a:solidFill>
-              </a:rPr>
-              <a:t>192 samples · 384 paths</a:t>
-            </a:r>
-          </a:p>
+              <a:defRPr sz="1200" b="1">
+                <a:solidFill>
+                  <a:srgbClr val="079455"/>
+                </a:solidFill>
+              </a:defRPr>
+            </a:pPr>
+            <a:r>
+              <a:rPr sz="1200" b="1">
+                <a:solidFill>
+                  <a:srgbClr val="079455"/>
+                </a:solidFill>
+              </a:rPr>
+              <a:t>已证明（仿真范围内）</a:t>
+            </a:r>
+          </a:p>
+        </p:txBody>
+      </p:sp>
+      <p:sp>
+        <p:nvSpPr>
+          <p:cNvPr id="107" name="">
+            <a:extLst xmlns:a="http://schemas.openxmlformats.org/drawingml/2006/main">
+              <a:ext uri="{FF2B5EF4-FFF2-40B4-BE49-F238E27FC236}">
+                <a16:creationId xmlns:a16="http://schemas.microsoft.com/office/drawing/2014/main" id="{45E07F35-4FC2-4DB4-8771-BAF8D42F0262}"/>
+              </a:ext>
+            </a:extLst>
+          </p:cNvPr>
+          <p:cNvSpPr>
+            <a:spLocks xmlns:a="http://schemas.openxmlformats.org/drawingml/2006/main" noGrp="1"/>
+          </p:cNvSpPr>
+          <p:nvPr/>
+        </p:nvSpPr>
+        <p:spPr>
+          <a:xfrm xmlns:a="http://schemas.openxmlformats.org/drawingml/2006/main">
+            <a:off x="876300" y="5762625"/>
+            <a:ext cx="4857750" cy="314325"/>
+          </a:xfrm>
+          <a:prstGeom xmlns:a="http://schemas.openxmlformats.org/drawingml/2006/main" prst="rect">
+            <a:avLst/>
+          </a:prstGeom>
+          <a:noFill xmlns:a="http://schemas.openxmlformats.org/drawingml/2006/main"/>
+          <a:ln xmlns:a="http://schemas.openxmlformats.org/drawingml/2006/main" w="0">
+            <a:noFill/>
+            <a:prstDash val="solid"/>
+          </a:ln>
+        </p:spPr>
+        <p:txBody>
+          <a:bodyPr xmlns:a="http://schemas.openxmlformats.org/drawingml/2006/main"/>
+          <a:lstStyle xmlns:a="http://schemas.openxmlformats.org/drawingml/2006/main"/>
           <a:p xmlns:a="http://schemas.openxmlformats.org/drawingml/2006/main">
             <a:pPr>
-              <a:defRPr sz="675">
-                <a:solidFill>
-                  <a:srgbClr val="5B7190"/>
-                </a:solidFill>
-              </a:defRPr>
-            </a:pPr>
-            <a:r>
-              <a:rPr sz="675">
-                <a:solidFill>
-                  <a:srgbClr val="5B7190"/>
-                </a:solidFill>
-              </a:rPr>
-              <a:t>6 anchors · 390 actual</a:t>
-            </a:r>
-          </a:p>
-        </p:txBody>
-      </p:sp>
-      <p:sp>
-        <p:nvSpPr>
-          <p:cNvPr id="49" name="">
-            <a:extLst xmlns:a="http://schemas.openxmlformats.org/drawingml/2006/main">
-              <a:ext uri="{FF2B5EF4-FFF2-40B4-BE49-F238E27FC236}">
-                <a16:creationId xmlns:a16="http://schemas.microsoft.com/office/drawing/2014/main" id="{D1DAAFE7-9CCF-4A33-AEE9-8834717F808F}"/>
-              </a:ext>
-            </a:extLst>
-          </p:cNvPr>
-          <p:cNvSpPr>
-            <a:spLocks xmlns:a="http://schemas.openxmlformats.org/drawingml/2006/main" noGrp="1"/>
-          </p:cNvSpPr>
-          <p:nvPr/>
-        </p:nvSpPr>
-        <p:spPr>
-          <a:xfrm xmlns:a="http://schemas.openxmlformats.org/drawingml/2006/main">
-            <a:off x="9572625" y="3448050"/>
-            <a:ext cx="1476375" cy="438150"/>
+              <a:defRPr sz="900">
+                <a:solidFill>
+                  <a:srgbClr val="132F4C"/>
+                </a:solidFill>
+              </a:defRPr>
+            </a:pPr>
+            <a:r>
+              <a:rPr sz="900">
+                <a:solidFill>
+                  <a:srgbClr val="132F4C"/>
+                </a:solidFill>
+              </a:rPr>
+              <a:t>冻结控制链在确定性、误差、固定种子、跨日相关与尾部测试中保持可追溯执行/会计证据。</a:t>
+            </a:r>
+          </a:p>
+        </p:txBody>
+      </p:sp>
+      <p:sp>
+        <p:nvSpPr>
+          <p:cNvPr id="108" name="">
+            <a:extLst xmlns:a="http://schemas.openxmlformats.org/drawingml/2006/main">
+              <a:ext uri="{FF2B5EF4-FFF2-40B4-BE49-F238E27FC236}">
+                <a16:creationId xmlns:a16="http://schemas.microsoft.com/office/drawing/2014/main" id="{14461BAF-5310-4716-9FC0-19063CA51ED6}"/>
+              </a:ext>
+            </a:extLst>
+          </p:cNvPr>
+          <p:cNvSpPr>
+            <a:spLocks xmlns:a="http://schemas.openxmlformats.org/drawingml/2006/main" noGrp="1"/>
+          </p:cNvSpPr>
+          <p:nvPr/>
+        </p:nvSpPr>
+        <p:spPr>
+          <a:xfrm xmlns:a="http://schemas.openxmlformats.org/drawingml/2006/main">
+            <a:off x="6238875" y="5286375"/>
+            <a:ext cx="5286375" cy="904875"/>
+          </a:xfrm>
+          <a:prstGeom xmlns:a="http://schemas.openxmlformats.org/drawingml/2006/main" prst="rect">
+            <a:avLst/>
+          </a:prstGeom>
+          <a:solidFill xmlns:a="http://schemas.openxmlformats.org/drawingml/2006/main">
+            <a:srgbClr val="FFFFFF"/>
+          </a:solidFill>
+          <a:ln xmlns:a="http://schemas.openxmlformats.org/drawingml/2006/main" w="9525">
+            <a:solidFill>
+              <a:srgbClr val="D7E3EE"/>
+            </a:solidFill>
+            <a:prstDash val="solid"/>
+          </a:ln>
+        </p:spPr>
+      </p:sp>
+      <p:sp>
+        <p:nvSpPr>
+          <p:cNvPr id="109" name="">
+            <a:extLst xmlns:a="http://schemas.openxmlformats.org/drawingml/2006/main">
+              <a:ext uri="{FF2B5EF4-FFF2-40B4-BE49-F238E27FC236}">
+                <a16:creationId xmlns:a16="http://schemas.microsoft.com/office/drawing/2014/main" id="{33B2F4BC-C343-4E69-808E-B74712A94143}"/>
+              </a:ext>
+            </a:extLst>
+          </p:cNvPr>
+          <p:cNvSpPr>
+            <a:spLocks xmlns:a="http://schemas.openxmlformats.org/drawingml/2006/main" noGrp="1"/>
+          </p:cNvSpPr>
+          <p:nvPr/>
+        </p:nvSpPr>
+        <p:spPr>
+          <a:xfrm xmlns:a="http://schemas.openxmlformats.org/drawingml/2006/main">
+            <a:off x="6238875" y="5286375"/>
+            <a:ext cx="66675" cy="904875"/>
+          </a:xfrm>
+          <a:prstGeom xmlns:a="http://schemas.openxmlformats.org/drawingml/2006/main" prst="rect">
+            <a:avLst/>
+          </a:prstGeom>
+          <a:solidFill xmlns:a="http://schemas.openxmlformats.org/drawingml/2006/main">
+            <a:srgbClr val="D92D20"/>
+          </a:solidFill>
+          <a:ln xmlns:a="http://schemas.openxmlformats.org/drawingml/2006/main" w="9525">
+            <a:solidFill>
+              <a:srgbClr val="D92D20"/>
+            </a:solidFill>
+            <a:prstDash val="solid"/>
+          </a:ln>
+        </p:spPr>
+      </p:sp>
+      <p:sp>
+        <p:nvSpPr>
+          <p:cNvPr id="110" name="">
+            <a:extLst xmlns:a="http://schemas.openxmlformats.org/drawingml/2006/main">
+              <a:ext uri="{FF2B5EF4-FFF2-40B4-BE49-F238E27FC236}">
+                <a16:creationId xmlns:a16="http://schemas.microsoft.com/office/drawing/2014/main" id="{04D14F65-ACED-4FC6-99D2-7AA54A238219}"/>
+              </a:ext>
+            </a:extLst>
+          </p:cNvPr>
+          <p:cNvSpPr>
+            <a:spLocks xmlns:a="http://schemas.openxmlformats.org/drawingml/2006/main" noGrp="1"/>
+          </p:cNvSpPr>
+          <p:nvPr/>
+        </p:nvSpPr>
+        <p:spPr>
+          <a:xfrm xmlns:a="http://schemas.openxmlformats.org/drawingml/2006/main">
+            <a:off x="6448425" y="5438775"/>
+            <a:ext cx="4762500" cy="228600"/>
           </a:xfrm>
           <a:prstGeom xmlns:a="http://schemas.openxmlformats.org/drawingml/2006/main" prst="rect">
             <a:avLst/>
@@ -14899,36 +17708,69 @@
           <a:lstStyle xmlns:a="http://schemas.openxmlformats.org/drawingml/2006/main"/>
           <a:p xmlns:a="http://schemas.openxmlformats.org/drawingml/2006/main">
             <a:pPr>
-              <a:defRPr sz="675">
-                <a:solidFill>
-                  <a:srgbClr val="5B7190"/>
-                </a:solidFill>
-              </a:defRPr>
-            </a:pPr>
-            <a:r>
-              <a:rPr sz="675">
-                <a:solidFill>
-                  <a:srgbClr val="5B7190"/>
-                </a:solidFill>
-              </a:rPr>
-              <a:t>60 scenarios · 420 scenario-days</a:t>
-            </a:r>
-          </a:p>
+              <a:defRPr sz="1200" b="1">
+                <a:solidFill>
+                  <a:srgbClr val="D92D20"/>
+                </a:solidFill>
+              </a:defRPr>
+            </a:pPr>
+            <a:r>
+              <a:rPr sz="1200" b="1">
+                <a:solidFill>
+                  <a:srgbClr val="D92D20"/>
+                </a:solidFill>
+              </a:rPr>
+              <a:t>尚未证明（产品化范围）</a:t>
+            </a:r>
+          </a:p>
+        </p:txBody>
+      </p:sp>
+      <p:sp>
+        <p:nvSpPr>
+          <p:cNvPr id="111" name="">
+            <a:extLst xmlns:a="http://schemas.openxmlformats.org/drawingml/2006/main">
+              <a:ext uri="{FF2B5EF4-FFF2-40B4-BE49-F238E27FC236}">
+                <a16:creationId xmlns:a16="http://schemas.microsoft.com/office/drawing/2014/main" id="{6AA77975-F3C5-46A7-BC76-83E2619354A7}"/>
+              </a:ext>
+            </a:extLst>
+          </p:cNvPr>
+          <p:cNvSpPr>
+            <a:spLocks xmlns:a="http://schemas.openxmlformats.org/drawingml/2006/main" noGrp="1"/>
+          </p:cNvSpPr>
+          <p:nvPr/>
+        </p:nvSpPr>
+        <p:spPr>
+          <a:xfrm xmlns:a="http://schemas.openxmlformats.org/drawingml/2006/main">
+            <a:off x="6448425" y="5762625"/>
+            <a:ext cx="4857750" cy="314325"/>
+          </a:xfrm>
+          <a:prstGeom xmlns:a="http://schemas.openxmlformats.org/drawingml/2006/main" prst="rect">
+            <a:avLst/>
+          </a:prstGeom>
+          <a:noFill xmlns:a="http://schemas.openxmlformats.org/drawingml/2006/main"/>
+          <a:ln xmlns:a="http://schemas.openxmlformats.org/drawingml/2006/main" w="0">
+            <a:noFill/>
+            <a:prstDash val="solid"/>
+          </a:ln>
+        </p:spPr>
+        <p:txBody>
+          <a:bodyPr xmlns:a="http://schemas.openxmlformats.org/drawingml/2006/main"/>
+          <a:lstStyle xmlns:a="http://schemas.openxmlformats.org/drawingml/2006/main"/>
           <a:p xmlns:a="http://schemas.openxmlformats.org/drawingml/2006/main">
             <a:pPr>
-              <a:defRPr sz="675">
-                <a:solidFill>
-                  <a:srgbClr val="5B7190"/>
-                </a:solidFill>
-              </a:defRPr>
-            </a:pPr>
-            <a:r>
-              <a:rPr sz="675">
-                <a:solidFill>
-                  <a:srgbClr val="5B7190"/>
-                </a:solidFill>
-              </a:rPr>
-              <a:t>126 paths · 882 daily</a:t>
+              <a:defRPr sz="900">
+                <a:solidFill>
+                  <a:srgbClr val="132F4C"/>
+                </a:solidFill>
+              </a:defRPr>
+            </a:pPr>
+            <a:r>
+              <a:rPr sz="900">
+                <a:solidFill>
+                  <a:srgbClr val="132F4C"/>
+                </a:solidFill>
+              </a:rPr>
+              <a:t>不等同于真实天气概率认证、HIL、PCS/BMS 通信、硬件保护、现场安全或客户部署就绪。</a:t>
             </a:r>
           </a:p>
         </p:txBody>
@@ -25159,10 +28001,10 @@
           <p:nvPr/>
         </p:nvPicPr>
         <p:blipFill>
-          <a:blip xmlns:r="http://schemas.openxmlformats.org/officeDocument/2006/relationships" xmlns:a="http://schemas.openxmlformats.org/drawingml/2006/main" r:embed="R7dd0afdb1bbc4f81">
+          <a:blip xmlns:r="http://schemas.openxmlformats.org/officeDocument/2006/relationships" xmlns:a="http://schemas.openxmlformats.org/drawingml/2006/main" r:embed="R4856d26970184cc5">
             <a:extLst>
               <a:ext uri="{96DAC541-7B7A-43D3-8B79-37D633B846F1}">
-                <asvg:svgBlip xmlns:asvg="http://schemas.microsoft.com/office/drawing/2016/SVG/main" r:embed="R2fff9e5891e04da6"/>
+                <asvg:svgBlip xmlns:asvg="http://schemas.microsoft.com/office/drawing/2016/SVG/main" r:embed="R7ab89265e6f94f03"/>
               </a:ext>
             </a:extLst>
           </a:blip>

</xml_diff>